<commit_message>
feat: Add script to programmatically generate presentation slide 5 showcasing simulation results and CI/CD details.
</commit_message>
<xml_diff>
--- a/docs/MBP-T05_ChildLock_결과발표_Final_v2.pptx
+++ b/docs/MBP-T05_ChildLock_결과발표_Final_v2.pptx
@@ -8707,13 +8707,13 @@
         <p:spPr>
           <a:xfrm>
             <a:off x="0" y="0"/>
-            <a:ext cx="12188952" cy="731520"/>
+            <a:ext cx="12188952" cy="6858000"/>
           </a:xfrm>
           <a:prstGeom prst="rect">
             <a:avLst/>
           </a:prstGeom>
           <a:solidFill>
-            <a:srgbClr val="003366"/>
+            <a:srgbClr val="FFFFFF"/>
           </a:solidFill>
           <a:ln>
             <a:noFill/>
@@ -8743,55 +8743,20 @@
       </p:sp>
       <p:sp>
         <p:nvSpPr>
-          <p:cNvPr id="3" name="TextBox 2"/>
-          <p:cNvSpPr txBox="1"/>
-          <p:nvPr/>
-        </p:nvSpPr>
-        <p:spPr>
-          <a:xfrm>
-            <a:off x="457200" y="182880"/>
-            <a:ext cx="10972800" cy="457200"/>
-          </a:xfrm>
-          <a:prstGeom prst="rect">
-            <a:avLst/>
-          </a:prstGeom>
-          <a:noFill/>
-        </p:spPr>
-        <p:txBody>
-          <a:bodyPr wrap="square">
-            <a:spAutoFit/>
-          </a:bodyPr>
-          <a:lstStyle/>
-          <a:p>
-            <a:pPr algn="l">
-              <a:defRPr sz="2400" b="1">
-                <a:solidFill>
-                  <a:srgbClr val="FFFFFF"/>
-                </a:solidFill>
-              </a:defRPr>
-            </a:pPr>
-            <a:r>
-              <a:t>05. 구현 결과</a:t>
-            </a:r>
-          </a:p>
-        </p:txBody>
-      </p:sp>
-      <p:sp>
-        <p:nvSpPr>
-          <p:cNvPr id="4" name="Rectangle 3"/>
+          <p:cNvPr id="3" name="Rectangle 2"/>
           <p:cNvSpPr/>
           <p:nvPr/>
         </p:nvSpPr>
         <p:spPr>
           <a:xfrm>
-            <a:off x="0" y="731520"/>
-            <a:ext cx="12188952" cy="45720"/>
+            <a:off x="0" y="0"/>
+            <a:ext cx="12188952" cy="731520"/>
           </a:xfrm>
           <a:prstGeom prst="rect">
             <a:avLst/>
           </a:prstGeom>
           <a:solidFill>
-            <a:srgbClr val="FF6A00"/>
+            <a:srgbClr val="001F54"/>
           </a:solidFill>
           <a:ln>
             <a:noFill/>
@@ -8821,27 +8786,58 @@
       </p:sp>
       <p:sp>
         <p:nvSpPr>
-          <p:cNvPr id="5" name="Rounded Rectangle 4"/>
+          <p:cNvPr id="4" name="TextBox 3"/>
+          <p:cNvSpPr txBox="1"/>
+          <p:nvPr/>
+        </p:nvSpPr>
+        <p:spPr>
+          <a:xfrm>
+            <a:off x="365760" y="137160"/>
+            <a:ext cx="10972800" cy="457200"/>
+          </a:xfrm>
+          <a:prstGeom prst="rect">
+            <a:avLst/>
+          </a:prstGeom>
+          <a:noFill/>
+        </p:spPr>
+        <p:txBody>
+          <a:bodyPr wrap="square">
+            <a:spAutoFit/>
+          </a:bodyPr>
+          <a:lstStyle/>
+          <a:p>
+            <a:pPr algn="l"/>
+            <a:r>
+              <a:rPr sz="2400" b="1">
+                <a:solidFill>
+                  <a:srgbClr val="FFFFFF"/>
+                </a:solidFill>
+                <a:latin typeface="Malgun Gothic"/>
+              </a:rPr>
+              <a:t>05. 구현 결과 (Implementation Results)</a:t>
+            </a:r>
+          </a:p>
+        </p:txBody>
+      </p:sp>
+      <p:sp>
+        <p:nvSpPr>
+          <p:cNvPr id="5" name="Rectangle 4"/>
           <p:cNvSpPr/>
           <p:nvPr/>
         </p:nvSpPr>
         <p:spPr>
           <a:xfrm>
-            <a:off x="457200" y="1188720"/>
-            <a:ext cx="5303520" cy="5131130"/>
-          </a:xfrm>
-          <a:prstGeom prst="roundRect">
-            <a:avLst>
-              <a:gd name="adj" fmla="val 16667"/>
-            </a:avLst>
+            <a:off x="0" y="731520"/>
+            <a:ext cx="12188952" cy="45720"/>
+          </a:xfrm>
+          <a:prstGeom prst="rect">
+            <a:avLst/>
           </a:prstGeom>
           <a:solidFill>
-            <a:srgbClr val="f5f5f5"/>
+            <a:srgbClr val="FF8C00"/>
           </a:solidFill>
           <a:ln>
-            <a:solidFill>
-              <a:srgbClr val="0066b2"/>
-            </a:solidFill>
+            <a:noFill/>
           </a:ln>
         </p:spPr>
         <p:style>
@@ -8859,38 +8855,33 @@
           </a:fontRef>
         </p:style>
         <p:txBody>
-          <a:bodyPr anchor="ctr"/>
-          <a:lstStyle/>
-          <a:p>
-            <a:pPr lvl="0" algn="ctr">
-              <a:defRPr/>
-            </a:pPr>
-            <a:endParaRPr lang="ko-KR" altLang="en-US"/>
-          </a:p>
-        </p:txBody>
-      </p:sp>
-      <p:sp>
-        <p:nvSpPr>
-          <p:cNvPr id="8" name="Rounded Rectangle 7"/>
+          <a:bodyPr rtlCol="0" anchor="ctr"/>
+          <a:lstStyle/>
+          <a:p>
+            <a:pPr algn="ctr"/>
+          </a:p>
+        </p:txBody>
+      </p:sp>
+      <p:sp>
+        <p:nvSpPr>
+          <p:cNvPr id="6" name="Rounded Rectangle 5"/>
           <p:cNvSpPr/>
           <p:nvPr/>
         </p:nvSpPr>
         <p:spPr>
           <a:xfrm>
-            <a:off x="6449440" y="1188720"/>
-            <a:ext cx="5371556" cy="5131130"/>
+            <a:off x="196595" y="1097280"/>
+            <a:ext cx="5669280" cy="5303520"/>
           </a:xfrm>
           <a:prstGeom prst="roundRect">
-            <a:avLst>
-              <a:gd name="adj" fmla="val 16667"/>
-            </a:avLst>
+            <a:avLst/>
           </a:prstGeom>
           <a:solidFill>
-            <a:srgbClr val="f5f5f5"/>
+            <a:srgbClr val="FFFFFF"/>
           </a:solidFill>
-          <a:ln>
+          <a:ln w="12700">
             <a:solidFill>
-              <a:srgbClr val="0066b2"/>
+              <a:srgbClr val="DEE2E6"/>
             </a:solidFill>
           </a:ln>
         </p:spPr>
@@ -8909,48 +8900,561 @@
           </a:fontRef>
         </p:style>
         <p:txBody>
-          <a:bodyPr anchor="ctr"/>
-          <a:lstStyle/>
-          <a:p>
-            <a:pPr lvl="0" algn="ctr">
-              <a:defRPr/>
-            </a:pPr>
-            <a:endParaRPr lang="ko-KR" altLang="en-US"/>
-          </a:p>
-        </p:txBody>
-      </p:sp>
-      <p:sp>
-        <p:nvSpPr>
-          <p:cNvPr id="17" name="TextBox 16"/>
-          <p:cNvSpPr txBox="1"/>
-          <p:nvPr/>
-        </p:nvSpPr>
-        <p:spPr>
-          <a:xfrm>
-            <a:off x="457200" y="6583680"/>
-            <a:ext cx="10972800" cy="274320"/>
-          </a:xfrm>
-          <a:prstGeom prst="rect">
-            <a:avLst/>
-          </a:prstGeom>
-          <a:noFill/>
-        </p:spPr>
-        <p:txBody>
-          <a:bodyPr wrap="square">
-            <a:spAutoFit/>
-          </a:bodyPr>
-          <a:lstStyle/>
-          <a:p>
-            <a:pPr algn="r">
-              <a:defRPr sz="1000" b="0">
-                <a:solidFill>
-                  <a:srgbClr val="808080"/>
-                </a:solidFill>
-              </a:defRPr>
-            </a:pPr>
-            <a:r>
-              <a:t>MOBIUS BOOTCAMP 1기 | PBL 결과발표 | 6/10</a:t>
-            </a:r>
+          <a:bodyPr rtlCol="0" anchor="ctr"/>
+          <a:lstStyle/>
+          <a:p>
+            <a:pPr algn="ctr"/>
+          </a:p>
+        </p:txBody>
+      </p:sp>
+      <p:sp>
+        <p:nvSpPr>
+          <p:cNvPr id="7" name="TextBox 6"/>
+          <p:cNvSpPr txBox="1"/>
+          <p:nvPr/>
+        </p:nvSpPr>
+        <p:spPr>
+          <a:xfrm>
+            <a:off x="196595" y="1234439"/>
+            <a:ext cx="5669280" cy="365760"/>
+          </a:xfrm>
+          <a:prstGeom prst="rect">
+            <a:avLst/>
+          </a:prstGeom>
+          <a:noFill/>
+        </p:spPr>
+        <p:txBody>
+          <a:bodyPr wrap="square">
+            <a:spAutoFit/>
+          </a:bodyPr>
+          <a:lstStyle/>
+          <a:p>
+            <a:pPr algn="ctr"/>
+            <a:r>
+              <a:rPr sz="1600" b="1">
+                <a:solidFill>
+                  <a:srgbClr val="001F54"/>
+                </a:solidFill>
+                <a:latin typeface="Malgun Gothic"/>
+              </a:rPr>
+              <a:t>시뮬레이션 및 테스트 검증</a:t>
+            </a:r>
+          </a:p>
+        </p:txBody>
+      </p:sp>
+      <p:sp>
+        <p:nvSpPr>
+          <p:cNvPr id="8" name="Rounded Rectangle 7"/>
+          <p:cNvSpPr/>
+          <p:nvPr/>
+        </p:nvSpPr>
+        <p:spPr>
+          <a:xfrm>
+            <a:off x="379475" y="1737360"/>
+            <a:ext cx="5303520" cy="2194560"/>
+          </a:xfrm>
+          <a:prstGeom prst="roundRect">
+            <a:avLst/>
+          </a:prstGeom>
+          <a:solidFill>
+            <a:srgbClr val="1E1E1E"/>
+          </a:solidFill>
+          <a:ln>
+            <a:noFill/>
+          </a:ln>
+        </p:spPr>
+        <p:style>
+          <a:lnRef idx="1">
+            <a:schemeClr val="accent1"/>
+          </a:lnRef>
+          <a:fillRef idx="3">
+            <a:schemeClr val="accent1"/>
+          </a:fillRef>
+          <a:effectRef idx="2">
+            <a:schemeClr val="accent1"/>
+          </a:effectRef>
+          <a:fontRef idx="minor">
+            <a:schemeClr val="lt1"/>
+          </a:fontRef>
+        </p:style>
+        <p:txBody>
+          <a:bodyPr rtlCol="0" anchor="ctr"/>
+          <a:lstStyle/>
+          <a:p>
+            <a:pPr algn="ctr"/>
+          </a:p>
+        </p:txBody>
+      </p:sp>
+      <p:sp>
+        <p:nvSpPr>
+          <p:cNvPr id="9" name="Rounded Rectangle 8"/>
+          <p:cNvSpPr/>
+          <p:nvPr/>
+        </p:nvSpPr>
+        <p:spPr>
+          <a:xfrm>
+            <a:off x="470915" y="1828800"/>
+            <a:ext cx="109728" cy="109728"/>
+          </a:xfrm>
+          <a:prstGeom prst="roundRect">
+            <a:avLst/>
+          </a:prstGeom>
+          <a:solidFill>
+            <a:srgbClr val="FF5F56"/>
+          </a:solidFill>
+          <a:ln>
+            <a:noFill/>
+          </a:ln>
+        </p:spPr>
+        <p:style>
+          <a:lnRef idx="1">
+            <a:schemeClr val="accent1"/>
+          </a:lnRef>
+          <a:fillRef idx="3">
+            <a:schemeClr val="accent1"/>
+          </a:fillRef>
+          <a:effectRef idx="2">
+            <a:schemeClr val="accent1"/>
+          </a:effectRef>
+          <a:fontRef idx="minor">
+            <a:schemeClr val="lt1"/>
+          </a:fontRef>
+        </p:style>
+        <p:txBody>
+          <a:bodyPr rtlCol="0" anchor="ctr"/>
+          <a:lstStyle/>
+          <a:p>
+            <a:pPr algn="ctr"/>
+          </a:p>
+        </p:txBody>
+      </p:sp>
+      <p:sp>
+        <p:nvSpPr>
+          <p:cNvPr id="10" name="Rounded Rectangle 9"/>
+          <p:cNvSpPr/>
+          <p:nvPr/>
+        </p:nvSpPr>
+        <p:spPr>
+          <a:xfrm>
+            <a:off x="653795" y="1828800"/>
+            <a:ext cx="109728" cy="109728"/>
+          </a:xfrm>
+          <a:prstGeom prst="roundRect">
+            <a:avLst/>
+          </a:prstGeom>
+          <a:solidFill>
+            <a:srgbClr val="FFBD2E"/>
+          </a:solidFill>
+          <a:ln>
+            <a:noFill/>
+          </a:ln>
+        </p:spPr>
+        <p:style>
+          <a:lnRef idx="1">
+            <a:schemeClr val="accent1"/>
+          </a:lnRef>
+          <a:fillRef idx="3">
+            <a:schemeClr val="accent1"/>
+          </a:fillRef>
+          <a:effectRef idx="2">
+            <a:schemeClr val="accent1"/>
+          </a:effectRef>
+          <a:fontRef idx="minor">
+            <a:schemeClr val="lt1"/>
+          </a:fontRef>
+        </p:style>
+        <p:txBody>
+          <a:bodyPr rtlCol="0" anchor="ctr"/>
+          <a:lstStyle/>
+          <a:p>
+            <a:pPr algn="ctr"/>
+          </a:p>
+        </p:txBody>
+      </p:sp>
+      <p:sp>
+        <p:nvSpPr>
+          <p:cNvPr id="11" name="Rounded Rectangle 10"/>
+          <p:cNvSpPr/>
+          <p:nvPr/>
+        </p:nvSpPr>
+        <p:spPr>
+          <a:xfrm>
+            <a:off x="836675" y="1828800"/>
+            <a:ext cx="109728" cy="109728"/>
+          </a:xfrm>
+          <a:prstGeom prst="roundRect">
+            <a:avLst/>
+          </a:prstGeom>
+          <a:solidFill>
+            <a:srgbClr val="27C93F"/>
+          </a:solidFill>
+          <a:ln>
+            <a:noFill/>
+          </a:ln>
+        </p:spPr>
+        <p:style>
+          <a:lnRef idx="1">
+            <a:schemeClr val="accent1"/>
+          </a:lnRef>
+          <a:fillRef idx="3">
+            <a:schemeClr val="accent1"/>
+          </a:fillRef>
+          <a:effectRef idx="2">
+            <a:schemeClr val="accent1"/>
+          </a:effectRef>
+          <a:fontRef idx="minor">
+            <a:schemeClr val="lt1"/>
+          </a:fontRef>
+        </p:style>
+        <p:txBody>
+          <a:bodyPr rtlCol="0" anchor="ctr"/>
+          <a:lstStyle/>
+          <a:p>
+            <a:pPr algn="ctr"/>
+          </a:p>
+        </p:txBody>
+      </p:sp>
+      <p:sp>
+        <p:nvSpPr>
+          <p:cNvPr id="12" name="TextBox 11"/>
+          <p:cNvSpPr txBox="1"/>
+          <p:nvPr/>
+        </p:nvSpPr>
+        <p:spPr>
+          <a:xfrm>
+            <a:off x="470915" y="2011679"/>
+            <a:ext cx="5120640" cy="1828800"/>
+          </a:xfrm>
+          <a:prstGeom prst="rect">
+            <a:avLst/>
+          </a:prstGeom>
+          <a:noFill/>
+        </p:spPr>
+        <p:txBody>
+          <a:bodyPr wrap="square">
+            <a:spAutoFit/>
+          </a:bodyPr>
+          <a:lstStyle/>
+          <a:p>
+            <a:r>
+              <a:rPr sz="1100">
+                <a:solidFill>
+                  <a:srgbClr val="E0E0E0"/>
+                </a:solidFill>
+                <a:latin typeface="Consolas"/>
+              </a:rPr>
+              <a:t>[==========] Running 140 tests from 12 test suites.
+</a:t>
+            </a:r>
+          </a:p>
+          <a:p>
+            <a:r>
+              <a:rPr sz="1100">
+                <a:solidFill>
+                  <a:srgbClr val="81C784"/>
+                </a:solidFill>
+                <a:latin typeface="Consolas"/>
+              </a:rPr>
+              <a:t>[  PASSED  ] </a:t>
+            </a:r>
+            <a:r>
+              <a:rPr sz="1100">
+                <a:solidFill>
+                  <a:srgbClr val="E0E0E0"/>
+                </a:solidFill>
+                <a:latin typeface="Consolas"/>
+              </a:rPr>
+              <a:t>140 tests.
+</a:t>
+            </a:r>
+          </a:p>
+          <a:p>
+            <a:r>
+              <a:rPr sz="1100">
+                <a:solidFill>
+                  <a:srgbClr val="E0E0E0"/>
+                </a:solidFill>
+                <a:latin typeface="Consolas"/>
+              </a:rPr>
+              <a:t>Coverage: 100% (Branch)
+</a:t>
+            </a:r>
+          </a:p>
+          <a:p>
+            <a:r>
+              <a:rPr sz="1100">
+                <a:solidFill>
+                  <a:srgbClr val="E0E0E0"/>
+                </a:solidFill>
+                <a:latin typeface="Consolas"/>
+              </a:rPr>
+              <a:t>Cyclomatic Complexity Average: 7</a:t>
+            </a:r>
+          </a:p>
+        </p:txBody>
+      </p:sp>
+      <p:sp>
+        <p:nvSpPr>
+          <p:cNvPr id="13" name="Rectangle 12"/>
+          <p:cNvSpPr/>
+          <p:nvPr/>
+        </p:nvSpPr>
+        <p:spPr>
+          <a:xfrm>
+            <a:off x="379475" y="4206240"/>
+            <a:ext cx="5303520" cy="1920240"/>
+          </a:xfrm>
+          <a:prstGeom prst="rect">
+            <a:avLst/>
+          </a:prstGeom>
+          <a:solidFill>
+            <a:srgbClr val="FFFFFF"/>
+          </a:solidFill>
+          <a:ln w="12700">
+            <a:solidFill>
+              <a:srgbClr val="DEE2E6"/>
+            </a:solidFill>
+          </a:ln>
+        </p:spPr>
+        <p:style>
+          <a:lnRef idx="1">
+            <a:schemeClr val="accent1"/>
+          </a:lnRef>
+          <a:fillRef idx="3">
+            <a:schemeClr val="accent1"/>
+          </a:fillRef>
+          <a:effectRef idx="2">
+            <a:schemeClr val="accent1"/>
+          </a:effectRef>
+          <a:fontRef idx="minor">
+            <a:schemeClr val="lt1"/>
+          </a:fontRef>
+        </p:style>
+        <p:txBody>
+          <a:bodyPr rtlCol="0" anchor="ctr"/>
+          <a:lstStyle/>
+          <a:p>
+            <a:pPr algn="ctr"/>
+          </a:p>
+        </p:txBody>
+      </p:sp>
+      <p:sp>
+        <p:nvSpPr>
+          <p:cNvPr id="14" name="TextBox 13"/>
+          <p:cNvSpPr txBox="1"/>
+          <p:nvPr/>
+        </p:nvSpPr>
+        <p:spPr>
+          <a:xfrm>
+            <a:off x="470915" y="4297679"/>
+            <a:ext cx="5120640" cy="1737360"/>
+          </a:xfrm>
+          <a:prstGeom prst="rect">
+            <a:avLst/>
+          </a:prstGeom>
+          <a:noFill/>
+        </p:spPr>
+        <p:txBody>
+          <a:bodyPr wrap="square">
+            <a:spAutoFit/>
+          </a:bodyPr>
+          <a:lstStyle/>
+          <a:p>
+            <a:r>
+              <a:rPr sz="1000">
+                <a:solidFill>
+                  <a:srgbClr val="6C757D"/>
+                </a:solidFill>
+                <a:latin typeface="Consolas"/>
+              </a:rPr>
+              <a:t>=== Simulation System Log ===
+</a:t>
+            </a:r>
+          </a:p>
+          <a:p>
+            <a:r>
+              <a:rPr sz="1000">
+                <a:solidFill>
+                  <a:srgbClr val="005BBB"/>
+                </a:solidFill>
+                <a:latin typeface="Consolas"/>
+              </a:rPr>
+              <a:t>[VehicleSpeed: 0km/h] </a:t>
+            </a:r>
+            <a:r>
+              <a:rPr sz="1000">
+                <a:solidFill>
+                  <a:srgbClr val="212529"/>
+                </a:solidFill>
+                <a:latin typeface="Consolas"/>
+              </a:rPr>
+              <a:t>UserRequest -&gt; ManualLock</a:t>
+            </a:r>
+          </a:p>
+          <a:p>
+            <a:r>
+              <a:rPr sz="1000">
+                <a:solidFill>
+                  <a:srgbClr val="005BBB"/>
+                </a:solidFill>
+                <a:latin typeface="Consolas"/>
+              </a:rPr>
+              <a:t>[VehicleSpeed: 16km/h] </a:t>
+            </a:r>
+            <a:r>
+              <a:rPr sz="1000">
+                <a:solidFill>
+                  <a:srgbClr val="212529"/>
+                </a:solidFill>
+                <a:latin typeface="Consolas"/>
+              </a:rPr>
+              <a:t>-&gt; AUTO_LOCKED</a:t>
+            </a:r>
+          </a:p>
+          <a:p>
+            <a:r>
+              <a:rPr sz="1000">
+                <a:solidFill>
+                  <a:srgbClr val="005BBB"/>
+                </a:solidFill>
+                <a:latin typeface="Consolas"/>
+              </a:rPr>
+              <a:t>[CollisionDetec: TRUE] </a:t>
+            </a:r>
+            <a:r>
+              <a:rPr sz="1000">
+                <a:solidFill>
+                  <a:srgbClr val="212529"/>
+                </a:solidFill>
+                <a:latin typeface="Consolas"/>
+              </a:rPr>
+              <a:t>-&gt; EMERGENCY_RELEASED</a:t>
+            </a:r>
+          </a:p>
+        </p:txBody>
+      </p:sp>
+      <p:sp>
+        <p:nvSpPr>
+          <p:cNvPr id="15" name="Rounded Rectangle 14"/>
+          <p:cNvSpPr/>
+          <p:nvPr/>
+        </p:nvSpPr>
+        <p:spPr>
+          <a:xfrm>
+            <a:off x="6323076" y="1097280"/>
+            <a:ext cx="5669280" cy="5303520"/>
+          </a:xfrm>
+          <a:prstGeom prst="roundRect">
+            <a:avLst/>
+          </a:prstGeom>
+          <a:solidFill>
+            <a:srgbClr val="FFFFFF"/>
+          </a:solidFill>
+          <a:ln w="12700">
+            <a:solidFill>
+              <a:srgbClr val="DEE2E6"/>
+            </a:solidFill>
+          </a:ln>
+        </p:spPr>
+        <p:style>
+          <a:lnRef idx="1">
+            <a:schemeClr val="accent1"/>
+          </a:lnRef>
+          <a:fillRef idx="3">
+            <a:schemeClr val="accent1"/>
+          </a:fillRef>
+          <a:effectRef idx="2">
+            <a:schemeClr val="accent1"/>
+          </a:effectRef>
+          <a:fontRef idx="minor">
+            <a:schemeClr val="lt1"/>
+          </a:fontRef>
+        </p:style>
+        <p:txBody>
+          <a:bodyPr rtlCol="0" anchor="ctr"/>
+          <a:lstStyle/>
+          <a:p>
+            <a:pPr algn="ctr"/>
+          </a:p>
+        </p:txBody>
+      </p:sp>
+      <p:sp>
+        <p:nvSpPr>
+          <p:cNvPr id="16" name="TextBox 15"/>
+          <p:cNvSpPr txBox="1"/>
+          <p:nvPr/>
+        </p:nvSpPr>
+        <p:spPr>
+          <a:xfrm>
+            <a:off x="6323076" y="1234439"/>
+            <a:ext cx="5669280" cy="365760"/>
+          </a:xfrm>
+          <a:prstGeom prst="rect">
+            <a:avLst/>
+          </a:prstGeom>
+          <a:noFill/>
+        </p:spPr>
+        <p:txBody>
+          <a:bodyPr wrap="square">
+            <a:spAutoFit/>
+          </a:bodyPr>
+          <a:lstStyle/>
+          <a:p>
+            <a:pPr algn="ctr"/>
+            <a:r>
+              <a:rPr sz="1600" b="1">
+                <a:solidFill>
+                  <a:srgbClr val="001F54"/>
+                </a:solidFill>
+                <a:latin typeface="Malgun Gothic"/>
+              </a:rPr>
+              <a:t>CI/CD 및 형상 관리</a:t>
+            </a:r>
+          </a:p>
+        </p:txBody>
+      </p:sp>
+      <p:sp>
+        <p:nvSpPr>
+          <p:cNvPr id="17" name="Rounded Rectangle 16"/>
+          <p:cNvSpPr/>
+          <p:nvPr/>
+        </p:nvSpPr>
+        <p:spPr>
+          <a:xfrm>
+            <a:off x="6505956" y="1737360"/>
+            <a:ext cx="5303520" cy="2194560"/>
+          </a:xfrm>
+          <a:prstGeom prst="roundRect">
+            <a:avLst/>
+          </a:prstGeom>
+          <a:solidFill>
+            <a:srgbClr val="FFFFFF"/>
+          </a:solidFill>
+          <a:ln w="12700">
+            <a:solidFill>
+              <a:srgbClr val="DEE2E6"/>
+            </a:solidFill>
+          </a:ln>
+        </p:spPr>
+        <p:style>
+          <a:lnRef idx="1">
+            <a:schemeClr val="accent1"/>
+          </a:lnRef>
+          <a:fillRef idx="3">
+            <a:schemeClr val="accent1"/>
+          </a:fillRef>
+          <a:effectRef idx="2">
+            <a:schemeClr val="accent1"/>
+          </a:effectRef>
+          <a:fontRef idx="minor">
+            <a:schemeClr val="lt1"/>
+          </a:fontRef>
+        </p:style>
+        <p:txBody>
+          <a:bodyPr rtlCol="0" anchor="ctr"/>
+          <a:lstStyle/>
+          <a:p>
+            <a:pPr algn="ctr"/>
           </a:p>
         </p:txBody>
       </p:sp>
@@ -8962,150 +9466,1254 @@
         </p:nvSpPr>
         <p:spPr>
           <a:xfrm>
-            <a:off x="765114" y="1269613"/>
-            <a:ext cx="3860226" cy="223907"/>
-          </a:xfrm>
-          <a:prstGeom prst="rect">
-            <a:avLst/>
-          </a:prstGeom>
-          <a:noFill/>
-        </p:spPr>
-        <p:txBody>
-          <a:bodyPr wrap="none">
-            <a:spAutoFit/>
-          </a:bodyPr>
-          <a:lstStyle/>
-          <a:p>
-            <a:pPr lvl="0">
-              <a:defRPr/>
-            </a:pPr>
-            <a:r>
-              <a:rPr lang="en-US" altLang="ko-KR" sz="900" b="1">
-                <a:solidFill>
-                  <a:srgbClr val="00357e"/>
-                </a:solidFill>
-                <a:latin typeface="맑은 고딕"/>
-              </a:rPr>
-              <a:t>                       </a:t>
-            </a:r>
+            <a:off x="6597396" y="1828800"/>
+            <a:ext cx="5303520" cy="182880"/>
+          </a:xfrm>
+          <a:prstGeom prst="rect">
+            <a:avLst/>
+          </a:prstGeom>
+          <a:noFill/>
+        </p:spPr>
+        <p:txBody>
+          <a:bodyPr wrap="square">
+            <a:spAutoFit/>
+          </a:bodyPr>
+          <a:lstStyle/>
+          <a:p>
+            <a:pPr algn="l"/>
+            <a:r>
+              <a:rPr sz="1100" b="1">
+                <a:solidFill>
+                  <a:srgbClr val="212529"/>
+                </a:solidFill>
+                <a:latin typeface="Malgun Gothic"/>
+              </a:rPr>
+              <a:t>GitHub Actions Pipeline</a:t>
+            </a:r>
+          </a:p>
+        </p:txBody>
+      </p:sp>
+      <p:sp>
+        <p:nvSpPr>
+          <p:cNvPr id="19" name="TextBox 18"/>
+          <p:cNvSpPr txBox="1"/>
+          <p:nvPr/>
+        </p:nvSpPr>
+        <p:spPr>
+          <a:xfrm>
+            <a:off x="6597396" y="2057400"/>
+            <a:ext cx="5303520" cy="182880"/>
+          </a:xfrm>
+          <a:prstGeom prst="rect">
+            <a:avLst/>
+          </a:prstGeom>
+          <a:noFill/>
+        </p:spPr>
+        <p:txBody>
+          <a:bodyPr wrap="square">
+            <a:spAutoFit/>
+          </a:bodyPr>
+          <a:lstStyle/>
+          <a:p>
+            <a:pPr algn="l"/>
+            <a:r>
+              <a:rPr sz="900" b="0">
+                <a:solidFill>
+                  <a:srgbClr val="6C757D"/>
+                </a:solidFill>
+                <a:latin typeface="Malgun Gothic"/>
+              </a:rPr>
+              <a:t>Commit: a1b2c3d  |  Duration: 1m 32s</a:t>
+            </a:r>
+          </a:p>
+        </p:txBody>
+      </p:sp>
+      <p:sp>
+        <p:nvSpPr>
+          <p:cNvPr id="20" name="TextBox 19"/>
+          <p:cNvSpPr txBox="1"/>
+          <p:nvPr/>
+        </p:nvSpPr>
+        <p:spPr>
+          <a:xfrm>
+            <a:off x="6643116" y="2423160"/>
+            <a:ext cx="274320" cy="274320"/>
+          </a:xfrm>
+          <a:prstGeom prst="rect">
+            <a:avLst/>
+          </a:prstGeom>
+          <a:noFill/>
+        </p:spPr>
+        <p:txBody>
+          <a:bodyPr wrap="square">
+            <a:spAutoFit/>
+          </a:bodyPr>
+          <a:lstStyle/>
+          <a:p>
+            <a:pPr algn="l"/>
+            <a:r>
+              <a:rPr sz="1200" b="1">
+                <a:solidFill>
+                  <a:srgbClr val="00C853"/>
+                </a:solidFill>
+                <a:latin typeface="Segoe UI Symbol"/>
+              </a:rPr>
+              <a:t>✔</a:t>
+            </a:r>
+          </a:p>
+        </p:txBody>
+      </p:sp>
+      <p:sp>
+        <p:nvSpPr>
+          <p:cNvPr id="21" name="TextBox 20"/>
+          <p:cNvSpPr txBox="1"/>
+          <p:nvPr/>
+        </p:nvSpPr>
+        <p:spPr>
+          <a:xfrm>
+            <a:off x="6871716" y="2450592"/>
+            <a:ext cx="2743200" cy="228600"/>
+          </a:xfrm>
+          <a:prstGeom prst="rect">
+            <a:avLst/>
+          </a:prstGeom>
+          <a:noFill/>
+        </p:spPr>
+        <p:txBody>
+          <a:bodyPr wrap="square">
+            <a:spAutoFit/>
+          </a:bodyPr>
+          <a:lstStyle/>
+          <a:p>
+            <a:pPr algn="l"/>
+            <a:r>
+              <a:rPr sz="1000" b="1">
+                <a:solidFill>
+                  <a:srgbClr val="212529"/>
+                </a:solidFill>
+                <a:latin typeface="Malgun Gothic"/>
+              </a:rPr>
+              <a:t>Build (Ubuntu)</a:t>
+            </a:r>
+          </a:p>
+        </p:txBody>
+      </p:sp>
+      <p:sp>
+        <p:nvSpPr>
+          <p:cNvPr id="22" name="TextBox 21"/>
+          <p:cNvSpPr txBox="1"/>
+          <p:nvPr/>
+        </p:nvSpPr>
+        <p:spPr>
+          <a:xfrm>
+            <a:off x="6643116" y="2743200"/>
+            <a:ext cx="274320" cy="274320"/>
+          </a:xfrm>
+          <a:prstGeom prst="rect">
+            <a:avLst/>
+          </a:prstGeom>
+          <a:noFill/>
+        </p:spPr>
+        <p:txBody>
+          <a:bodyPr wrap="square">
+            <a:spAutoFit/>
+          </a:bodyPr>
+          <a:lstStyle/>
+          <a:p>
+            <a:pPr algn="l"/>
+            <a:r>
+              <a:rPr sz="1200" b="1">
+                <a:solidFill>
+                  <a:srgbClr val="00C853"/>
+                </a:solidFill>
+                <a:latin typeface="Segoe UI Symbol"/>
+              </a:rPr>
+              <a:t>✔</a:t>
+            </a:r>
+          </a:p>
+        </p:txBody>
+      </p:sp>
+      <p:sp>
+        <p:nvSpPr>
+          <p:cNvPr id="23" name="TextBox 22"/>
+          <p:cNvSpPr txBox="1"/>
+          <p:nvPr/>
+        </p:nvSpPr>
+        <p:spPr>
+          <a:xfrm>
+            <a:off x="6871716" y="2770632"/>
+            <a:ext cx="2743200" cy="228600"/>
+          </a:xfrm>
+          <a:prstGeom prst="rect">
+            <a:avLst/>
+          </a:prstGeom>
+          <a:noFill/>
+        </p:spPr>
+        <p:txBody>
+          <a:bodyPr wrap="square">
+            <a:spAutoFit/>
+          </a:bodyPr>
+          <a:lstStyle/>
+          <a:p>
+            <a:pPr algn="l"/>
+            <a:r>
+              <a:rPr sz="1000" b="1">
+                <a:solidFill>
+                  <a:srgbClr val="212529"/>
+                </a:solidFill>
+                <a:latin typeface="Malgun Gothic"/>
+              </a:rPr>
+              <a:t>Unit Tests (GTest)</a:t>
+            </a:r>
+          </a:p>
+        </p:txBody>
+      </p:sp>
+      <p:sp>
+        <p:nvSpPr>
+          <p:cNvPr id="24" name="TextBox 23"/>
+          <p:cNvSpPr txBox="1"/>
+          <p:nvPr/>
+        </p:nvSpPr>
+        <p:spPr>
+          <a:xfrm>
+            <a:off x="6643116" y="3063240"/>
+            <a:ext cx="274320" cy="274320"/>
+          </a:xfrm>
+          <a:prstGeom prst="rect">
+            <a:avLst/>
+          </a:prstGeom>
+          <a:noFill/>
+        </p:spPr>
+        <p:txBody>
+          <a:bodyPr wrap="square">
+            <a:spAutoFit/>
+          </a:bodyPr>
+          <a:lstStyle/>
+          <a:p>
+            <a:pPr algn="l"/>
+            <a:r>
+              <a:rPr sz="1200" b="1">
+                <a:solidFill>
+                  <a:srgbClr val="00C853"/>
+                </a:solidFill>
+                <a:latin typeface="Segoe UI Symbol"/>
+              </a:rPr>
+              <a:t>✔</a:t>
+            </a:r>
+          </a:p>
+        </p:txBody>
+      </p:sp>
+      <p:sp>
+        <p:nvSpPr>
+          <p:cNvPr id="25" name="TextBox 24"/>
+          <p:cNvSpPr txBox="1"/>
+          <p:nvPr/>
+        </p:nvSpPr>
+        <p:spPr>
+          <a:xfrm>
+            <a:off x="6871716" y="3090672"/>
+            <a:ext cx="2743200" cy="228600"/>
+          </a:xfrm>
+          <a:prstGeom prst="rect">
+            <a:avLst/>
+          </a:prstGeom>
+          <a:noFill/>
+        </p:spPr>
+        <p:txBody>
+          <a:bodyPr wrap="square">
+            <a:spAutoFit/>
+          </a:bodyPr>
+          <a:lstStyle/>
+          <a:p>
+            <a:pPr algn="l"/>
+            <a:r>
+              <a:rPr sz="1000" b="1">
+                <a:solidFill>
+                  <a:srgbClr val="212529"/>
+                </a:solidFill>
+                <a:latin typeface="Malgun Gothic"/>
+              </a:rPr>
+              <a:t>Static Analysis (Cppcheck)</a:t>
+            </a:r>
+          </a:p>
+        </p:txBody>
+      </p:sp>
+      <p:sp>
+        <p:nvSpPr>
+          <p:cNvPr id="26" name="TextBox 25"/>
+          <p:cNvSpPr txBox="1"/>
+          <p:nvPr/>
+        </p:nvSpPr>
+        <p:spPr>
+          <a:xfrm>
+            <a:off x="6643116" y="3383280"/>
+            <a:ext cx="274320" cy="274320"/>
+          </a:xfrm>
+          <a:prstGeom prst="rect">
+            <a:avLst/>
+          </a:prstGeom>
+          <a:noFill/>
+        </p:spPr>
+        <p:txBody>
+          <a:bodyPr wrap="square">
+            <a:spAutoFit/>
+          </a:bodyPr>
+          <a:lstStyle/>
+          <a:p>
+            <a:pPr algn="l"/>
+            <a:r>
+              <a:rPr sz="1200" b="1">
+                <a:solidFill>
+                  <a:srgbClr val="00C853"/>
+                </a:solidFill>
+                <a:latin typeface="Segoe UI Symbol"/>
+              </a:rPr>
+              <a:t>✔</a:t>
+            </a:r>
+          </a:p>
+        </p:txBody>
+      </p:sp>
+      <p:sp>
+        <p:nvSpPr>
+          <p:cNvPr id="27" name="TextBox 26"/>
+          <p:cNvSpPr txBox="1"/>
+          <p:nvPr/>
+        </p:nvSpPr>
+        <p:spPr>
+          <a:xfrm>
+            <a:off x="6871716" y="3410712"/>
+            <a:ext cx="2743200" cy="228600"/>
+          </a:xfrm>
+          <a:prstGeom prst="rect">
+            <a:avLst/>
+          </a:prstGeom>
+          <a:noFill/>
+        </p:spPr>
+        <p:txBody>
+          <a:bodyPr wrap="square">
+            <a:spAutoFit/>
+          </a:bodyPr>
+          <a:lstStyle/>
+          <a:p>
+            <a:pPr algn="l"/>
+            <a:r>
+              <a:rPr sz="1000" b="1">
+                <a:solidFill>
+                  <a:srgbClr val="212529"/>
+                </a:solidFill>
+                <a:latin typeface="Malgun Gothic"/>
+              </a:rPr>
+              <a:t>Code Complexity (Lizard)</a:t>
+            </a:r>
+          </a:p>
+        </p:txBody>
+      </p:sp>
+      <p:sp>
+        <p:nvSpPr>
+          <p:cNvPr id="28" name="Rounded Rectangle 27"/>
+          <p:cNvSpPr/>
+          <p:nvPr/>
+        </p:nvSpPr>
+        <p:spPr>
+          <a:xfrm>
+            <a:off x="6505956" y="4206240"/>
+            <a:ext cx="5303520" cy="1920240"/>
+          </a:xfrm>
+          <a:prstGeom prst="roundRect">
+            <a:avLst/>
+          </a:prstGeom>
+          <a:solidFill>
+            <a:srgbClr val="FFFFFF"/>
+          </a:solidFill>
+          <a:ln w="12700">
+            <a:solidFill>
+              <a:srgbClr val="DEE2E6"/>
+            </a:solidFill>
+          </a:ln>
+        </p:spPr>
+        <p:style>
+          <a:lnRef idx="1">
+            <a:schemeClr val="accent1"/>
+          </a:lnRef>
+          <a:fillRef idx="3">
+            <a:schemeClr val="accent1"/>
+          </a:fillRef>
+          <a:effectRef idx="2">
+            <a:schemeClr val="accent1"/>
+          </a:effectRef>
+          <a:fontRef idx="minor">
+            <a:schemeClr val="lt1"/>
+          </a:fontRef>
+        </p:style>
+        <p:txBody>
+          <a:bodyPr rtlCol="0" anchor="ctr"/>
+          <a:lstStyle/>
+          <a:p>
+            <a:pPr algn="ctr"/>
+          </a:p>
+        </p:txBody>
+      </p:sp>
+      <p:sp>
+        <p:nvSpPr>
+          <p:cNvPr id="29" name="TextBox 28"/>
+          <p:cNvSpPr txBox="1"/>
+          <p:nvPr/>
+        </p:nvSpPr>
+        <p:spPr>
+          <a:xfrm>
+            <a:off x="6597396" y="4297679"/>
+            <a:ext cx="5303520" cy="182880"/>
+          </a:xfrm>
+          <a:prstGeom prst="rect">
+            <a:avLst/>
+          </a:prstGeom>
+          <a:noFill/>
+        </p:spPr>
+        <p:txBody>
+          <a:bodyPr wrap="square">
+            <a:spAutoFit/>
+          </a:bodyPr>
+          <a:lstStyle/>
+          <a:p>
+            <a:pPr algn="l"/>
+            <a:r>
+              <a:rPr sz="1100" b="1">
+                <a:solidFill>
+                  <a:srgbClr val="212529"/>
+                </a:solidFill>
+                <a:latin typeface="Malgun Gothic"/>
+              </a:rPr>
+              <a:t>Branch Workflow</a:t>
+            </a:r>
+          </a:p>
+        </p:txBody>
+      </p:sp>
+      <p:sp>
+        <p:nvSpPr>
+          <p:cNvPr id="30" name="Rectangle 29"/>
+          <p:cNvSpPr/>
+          <p:nvPr/>
+        </p:nvSpPr>
+        <p:spPr>
+          <a:xfrm>
+            <a:off x="6780276" y="5303520"/>
+            <a:ext cx="4572000" cy="45720"/>
+          </a:xfrm>
+          <a:prstGeom prst="rect">
+            <a:avLst/>
+          </a:prstGeom>
+          <a:solidFill>
+            <a:srgbClr val="001F54"/>
+          </a:solidFill>
+          <a:ln>
+            <a:noFill/>
+          </a:ln>
+        </p:spPr>
+        <p:style>
+          <a:lnRef idx="1">
+            <a:schemeClr val="accent1"/>
+          </a:lnRef>
+          <a:fillRef idx="3">
+            <a:schemeClr val="accent1"/>
+          </a:fillRef>
+          <a:effectRef idx="2">
+            <a:schemeClr val="accent1"/>
+          </a:effectRef>
+          <a:fontRef idx="minor">
+            <a:schemeClr val="lt1"/>
+          </a:fontRef>
+        </p:style>
+        <p:txBody>
+          <a:bodyPr rtlCol="0" anchor="ctr"/>
+          <a:lstStyle/>
+          <a:p>
+            <a:pPr algn="ctr"/>
+          </a:p>
+        </p:txBody>
+      </p:sp>
+      <p:sp>
+        <p:nvSpPr>
+          <p:cNvPr id="31" name="TextBox 30"/>
+          <p:cNvSpPr txBox="1"/>
+          <p:nvPr/>
+        </p:nvSpPr>
+        <p:spPr>
+          <a:xfrm>
+            <a:off x="6780276" y="5029200"/>
+            <a:ext cx="731520" cy="182880"/>
+          </a:xfrm>
+          <a:prstGeom prst="rect">
+            <a:avLst/>
+          </a:prstGeom>
+          <a:noFill/>
+        </p:spPr>
+        <p:txBody>
+          <a:bodyPr wrap="square">
+            <a:spAutoFit/>
+          </a:bodyPr>
+          <a:lstStyle/>
+          <a:p>
+            <a:pPr algn="l"/>
             <a:r>
               <a:rPr sz="900" b="1">
                 <a:solidFill>
-                  <a:srgbClr val="00357e"/>
-                </a:solidFill>
-                <a:latin typeface="맑은 고딕"/>
-              </a:rPr>
-              <a:t>FG-01 플로우차트: 도어 잠금/해제 제어 (UC-1,2,3,4)</a:t>
-            </a:r>
-            <a:endParaRPr sz="900" b="1">
-              <a:solidFill>
-                <a:srgbClr val="00357e"/>
-              </a:solidFill>
-              <a:latin typeface="맑은 고딕"/>
-            </a:endParaRPr>
-          </a:p>
-        </p:txBody>
-      </p:sp>
-      <p:pic>
-        <p:nvPicPr>
-          <p:cNvPr id="19" name="Picture 18" descr="image.png"/>
-          <p:cNvPicPr>
-            <a:picLocks noChangeAspect="1"/>
-          </p:cNvPicPr>
-          <p:nvPr/>
-        </p:nvPicPr>
-        <p:blipFill rotWithShape="1">
-          <a:blip r:embed="rId2"/>
-          <a:stretch>
-            <a:fillRect/>
-          </a:stretch>
-        </p:blipFill>
-        <p:spPr>
-          <a:xfrm>
-            <a:off x="765114" y="1702418"/>
-            <a:ext cx="4695032" cy="4209670"/>
-          </a:xfrm>
-          <a:prstGeom prst="rect">
-            <a:avLst/>
-          </a:prstGeom>
-        </p:spPr>
-      </p:pic>
-      <p:sp>
-        <p:nvSpPr>
-          <p:cNvPr id="20" name="TextBox 19"/>
-          <p:cNvSpPr txBox="1"/>
-          <p:nvPr/>
-        </p:nvSpPr>
-        <p:spPr>
-          <a:xfrm>
-            <a:off x="6126479" y="1234440"/>
-            <a:ext cx="4194811" cy="220980"/>
-          </a:xfrm>
-          <a:prstGeom prst="rect">
-            <a:avLst/>
-          </a:prstGeom>
-          <a:noFill/>
-        </p:spPr>
-        <p:txBody>
-          <a:bodyPr wrap="none">
-            <a:spAutoFit/>
-          </a:bodyPr>
-          <a:lstStyle/>
-          <a:p>
-            <a:pPr lvl="0">
-              <a:defRPr/>
-            </a:pPr>
-            <a:r>
-              <a:rPr lang="en-US" altLang="ko-KR" sz="900" b="1">
-                <a:solidFill>
-                  <a:srgbClr val="00357e"/>
-                </a:solidFill>
-                <a:latin typeface="맑은 고딕"/>
-              </a:rPr>
-              <a:t>                                         </a:t>
-            </a:r>
+                  <a:srgbClr val="001F54"/>
+                </a:solidFill>
+                <a:latin typeface="Malgun Gothic"/>
+              </a:rPr>
+              <a:t>main</a:t>
+            </a:r>
+          </a:p>
+        </p:txBody>
+      </p:sp>
+      <p:sp>
+        <p:nvSpPr>
+          <p:cNvPr id="32" name="Rectangle 31"/>
+          <p:cNvSpPr/>
+          <p:nvPr/>
+        </p:nvSpPr>
+        <p:spPr>
+          <a:xfrm>
+            <a:off x="7237476" y="4754879"/>
+            <a:ext cx="1554480" cy="36576"/>
+          </a:xfrm>
+          <a:prstGeom prst="rect">
+            <a:avLst/>
+          </a:prstGeom>
+          <a:solidFill>
+            <a:srgbClr val="FF8C00"/>
+          </a:solidFill>
+          <a:ln>
+            <a:noFill/>
+          </a:ln>
+        </p:spPr>
+        <p:style>
+          <a:lnRef idx="1">
+            <a:schemeClr val="accent1"/>
+          </a:lnRef>
+          <a:fillRef idx="3">
+            <a:schemeClr val="accent1"/>
+          </a:fillRef>
+          <a:effectRef idx="2">
+            <a:schemeClr val="accent1"/>
+          </a:effectRef>
+          <a:fontRef idx="minor">
+            <a:schemeClr val="lt1"/>
+          </a:fontRef>
+        </p:style>
+        <p:txBody>
+          <a:bodyPr rtlCol="0" anchor="ctr"/>
+          <a:lstStyle/>
+          <a:p>
+            <a:pPr algn="ctr"/>
+          </a:p>
+        </p:txBody>
+      </p:sp>
+      <p:sp>
+        <p:nvSpPr>
+          <p:cNvPr id="33" name="Straight Connector 32"/>
+          <p:cNvSpPr/>
+          <p:nvPr/>
+        </p:nvSpPr>
+        <p:spPr>
+          <a:xfrm>
+            <a:off x="8791956" y="4754879"/>
+            <a:ext cx="457200" cy="548640"/>
+          </a:xfrm>
+          <a:prstGeom prst="lineInv">
+            <a:avLst/>
+          </a:prstGeom>
+        </p:spPr>
+        <p:style>
+          <a:lnRef idx="1">
+            <a:schemeClr val="accent1"/>
+          </a:lnRef>
+          <a:fillRef idx="3">
+            <a:schemeClr val="accent1"/>
+          </a:fillRef>
+          <a:effectRef idx="2">
+            <a:schemeClr val="accent1"/>
+          </a:effectRef>
+          <a:fontRef idx="minor">
+            <a:schemeClr val="lt1"/>
+          </a:fontRef>
+        </p:style>
+        <p:txBody>
+          <a:bodyPr rtlCol="0" anchor="ctr"/>
+          <a:lstStyle/>
+          <a:p>
+            <a:pPr algn="ctr"/>
+          </a:p>
+        </p:txBody>
+      </p:sp>
+      <p:sp>
+        <p:nvSpPr>
+          <p:cNvPr id="34" name="Rectangle 33"/>
+          <p:cNvSpPr/>
+          <p:nvPr/>
+        </p:nvSpPr>
+        <p:spPr>
+          <a:xfrm>
+            <a:off x="8791956" y="4754879"/>
+            <a:ext cx="36576" cy="548640"/>
+          </a:xfrm>
+          <a:prstGeom prst="rect">
+            <a:avLst/>
+          </a:prstGeom>
+          <a:solidFill>
+            <a:srgbClr val="FF8C00"/>
+          </a:solidFill>
+          <a:ln>
+            <a:noFill/>
+          </a:ln>
+        </p:spPr>
+        <p:style>
+          <a:lnRef idx="1">
+            <a:schemeClr val="accent1"/>
+          </a:lnRef>
+          <a:fillRef idx="3">
+            <a:schemeClr val="accent1"/>
+          </a:fillRef>
+          <a:effectRef idx="2">
+            <a:schemeClr val="accent1"/>
+          </a:effectRef>
+          <a:fontRef idx="minor">
+            <a:schemeClr val="lt1"/>
+          </a:fontRef>
+        </p:style>
+        <p:txBody>
+          <a:bodyPr rtlCol="0" anchor="ctr"/>
+          <a:lstStyle/>
+          <a:p>
+            <a:pPr algn="ctr"/>
+          </a:p>
+        </p:txBody>
+      </p:sp>
+      <p:sp>
+        <p:nvSpPr>
+          <p:cNvPr id="35" name="TextBox 34"/>
+          <p:cNvSpPr txBox="1"/>
+          <p:nvPr/>
+        </p:nvSpPr>
+        <p:spPr>
+          <a:xfrm>
+            <a:off x="7237476" y="4526279"/>
+            <a:ext cx="1371600" cy="182880"/>
+          </a:xfrm>
+          <a:prstGeom prst="rect">
+            <a:avLst/>
+          </a:prstGeom>
+          <a:noFill/>
+        </p:spPr>
+        <p:txBody>
+          <a:bodyPr wrap="square">
+            <a:spAutoFit/>
+          </a:bodyPr>
+          <a:lstStyle/>
+          <a:p>
+            <a:pPr algn="l"/>
             <a:r>
               <a:rPr sz="900" b="1">
                 <a:solidFill>
-                  <a:srgbClr val="00357e"/>
-                </a:solidFill>
-                <a:latin typeface="맑은 고딕"/>
-              </a:rPr>
-              <a:t>FG-02 플로우차트: 하차 안전 보조 (UC-5,6,7)</a:t>
-            </a:r>
-            <a:endParaRPr sz="900" b="1">
-              <a:solidFill>
-                <a:srgbClr val="00357e"/>
-              </a:solidFill>
-              <a:latin typeface="맑은 고딕"/>
-            </a:endParaRPr>
-          </a:p>
-        </p:txBody>
-      </p:sp>
-      <p:pic>
-        <p:nvPicPr>
-          <p:cNvPr id="26" name="그림 25"/>
-          <p:cNvPicPr>
-            <a:picLocks noChangeAspect="1"/>
-          </p:cNvPicPr>
-          <p:nvPr/>
-        </p:nvPicPr>
-        <p:blipFill rotWithShape="1">
-          <a:blip r:embed="rId3"/>
-          <a:stretch>
-            <a:fillRect/>
-          </a:stretch>
-        </p:blipFill>
-        <p:spPr>
-          <a:xfrm>
-            <a:off x="6710794" y="1585912"/>
-            <a:ext cx="4917126" cy="4403408"/>
-          </a:xfrm>
-          <a:prstGeom prst="rect">
-            <a:avLst/>
-          </a:prstGeom>
-        </p:spPr>
-      </p:pic>
+                  <a:srgbClr val="FF8C00"/>
+                </a:solidFill>
+                <a:latin typeface="Malgun Gothic"/>
+              </a:rPr>
+              <a:t>feat/rear-radar</a:t>
+            </a:r>
+          </a:p>
+        </p:txBody>
+      </p:sp>
+      <p:sp>
+        <p:nvSpPr>
+          <p:cNvPr id="36" name="Rectangle 35"/>
+          <p:cNvSpPr/>
+          <p:nvPr/>
+        </p:nvSpPr>
+        <p:spPr>
+          <a:xfrm>
+            <a:off x="7877556" y="5760720"/>
+            <a:ext cx="1371600" cy="36576"/>
+          </a:xfrm>
+          <a:prstGeom prst="rect">
+            <a:avLst/>
+          </a:prstGeom>
+          <a:solidFill>
+            <a:srgbClr val="00BCD4"/>
+          </a:solidFill>
+          <a:ln>
+            <a:noFill/>
+          </a:ln>
+        </p:spPr>
+        <p:style>
+          <a:lnRef idx="1">
+            <a:schemeClr val="accent1"/>
+          </a:lnRef>
+          <a:fillRef idx="3">
+            <a:schemeClr val="accent1"/>
+          </a:fillRef>
+          <a:effectRef idx="2">
+            <a:schemeClr val="accent1"/>
+          </a:effectRef>
+          <a:fontRef idx="minor">
+            <a:schemeClr val="lt1"/>
+          </a:fontRef>
+        </p:style>
+        <p:txBody>
+          <a:bodyPr rtlCol="0" anchor="ctr"/>
+          <a:lstStyle/>
+          <a:p>
+            <a:pPr algn="ctr"/>
+          </a:p>
+        </p:txBody>
+      </p:sp>
+      <p:sp>
+        <p:nvSpPr>
+          <p:cNvPr id="37" name="Rectangle 36"/>
+          <p:cNvSpPr/>
+          <p:nvPr/>
+        </p:nvSpPr>
+        <p:spPr>
+          <a:xfrm>
+            <a:off x="9249156" y="5303520"/>
+            <a:ext cx="36576" cy="457200"/>
+          </a:xfrm>
+          <a:prstGeom prst="rect">
+            <a:avLst/>
+          </a:prstGeom>
+          <a:solidFill>
+            <a:srgbClr val="00BCD4"/>
+          </a:solidFill>
+          <a:ln>
+            <a:noFill/>
+          </a:ln>
+        </p:spPr>
+        <p:style>
+          <a:lnRef idx="1">
+            <a:schemeClr val="accent1"/>
+          </a:lnRef>
+          <a:fillRef idx="3">
+            <a:schemeClr val="accent1"/>
+          </a:fillRef>
+          <a:effectRef idx="2">
+            <a:schemeClr val="accent1"/>
+          </a:effectRef>
+          <a:fontRef idx="minor">
+            <a:schemeClr val="lt1"/>
+          </a:fontRef>
+        </p:style>
+        <p:txBody>
+          <a:bodyPr rtlCol="0" anchor="ctr"/>
+          <a:lstStyle/>
+          <a:p>
+            <a:pPr algn="ctr"/>
+          </a:p>
+        </p:txBody>
+      </p:sp>
+      <p:sp>
+        <p:nvSpPr>
+          <p:cNvPr id="38" name="TextBox 37"/>
+          <p:cNvSpPr txBox="1"/>
+          <p:nvPr/>
+        </p:nvSpPr>
+        <p:spPr>
+          <a:xfrm>
+            <a:off x="7877556" y="5806440"/>
+            <a:ext cx="1371600" cy="182880"/>
+          </a:xfrm>
+          <a:prstGeom prst="rect">
+            <a:avLst/>
+          </a:prstGeom>
+          <a:noFill/>
+        </p:spPr>
+        <p:txBody>
+          <a:bodyPr wrap="square">
+            <a:spAutoFit/>
+          </a:bodyPr>
+          <a:lstStyle/>
+          <a:p>
+            <a:pPr algn="l"/>
+            <a:r>
+              <a:rPr sz="900" b="1">
+                <a:solidFill>
+                  <a:srgbClr val="00BCD4"/>
+                </a:solidFill>
+                <a:latin typeface="Malgun Gothic"/>
+              </a:rPr>
+              <a:t>fix/crash-logic</a:t>
+            </a:r>
+          </a:p>
+        </p:txBody>
+      </p:sp>
+      <p:sp>
+        <p:nvSpPr>
+          <p:cNvPr id="39" name="Oval 38"/>
+          <p:cNvSpPr/>
+          <p:nvPr/>
+        </p:nvSpPr>
+        <p:spPr>
+          <a:xfrm>
+            <a:off x="7164324" y="5253228"/>
+            <a:ext cx="146304" cy="146304"/>
+          </a:xfrm>
+          <a:prstGeom prst="ellipse">
+            <a:avLst/>
+          </a:prstGeom>
+          <a:solidFill>
+            <a:srgbClr val="FFFFFF"/>
+          </a:solidFill>
+          <a:ln w="25400">
+            <a:solidFill>
+              <a:srgbClr val="001F54"/>
+            </a:solidFill>
+          </a:ln>
+        </p:spPr>
+        <p:style>
+          <a:lnRef idx="1">
+            <a:schemeClr val="accent1"/>
+          </a:lnRef>
+          <a:fillRef idx="3">
+            <a:schemeClr val="accent1"/>
+          </a:fillRef>
+          <a:effectRef idx="2">
+            <a:schemeClr val="accent1"/>
+          </a:effectRef>
+          <a:fontRef idx="minor">
+            <a:schemeClr val="lt1"/>
+          </a:fontRef>
+        </p:style>
+        <p:txBody>
+          <a:bodyPr rtlCol="0" anchor="ctr"/>
+          <a:lstStyle/>
+          <a:p>
+            <a:pPr algn="ctr"/>
+          </a:p>
+        </p:txBody>
+      </p:sp>
+      <p:sp>
+        <p:nvSpPr>
+          <p:cNvPr id="40" name="Oval 39"/>
+          <p:cNvSpPr/>
+          <p:nvPr/>
+        </p:nvSpPr>
+        <p:spPr>
+          <a:xfrm>
+            <a:off x="7804404" y="5253228"/>
+            <a:ext cx="146304" cy="146304"/>
+          </a:xfrm>
+          <a:prstGeom prst="ellipse">
+            <a:avLst/>
+          </a:prstGeom>
+          <a:solidFill>
+            <a:srgbClr val="FFFFFF"/>
+          </a:solidFill>
+          <a:ln w="25400">
+            <a:solidFill>
+              <a:srgbClr val="001F54"/>
+            </a:solidFill>
+          </a:ln>
+        </p:spPr>
+        <p:style>
+          <a:lnRef idx="1">
+            <a:schemeClr val="accent1"/>
+          </a:lnRef>
+          <a:fillRef idx="3">
+            <a:schemeClr val="accent1"/>
+          </a:fillRef>
+          <a:effectRef idx="2">
+            <a:schemeClr val="accent1"/>
+          </a:effectRef>
+          <a:fontRef idx="minor">
+            <a:schemeClr val="lt1"/>
+          </a:fontRef>
+        </p:style>
+        <p:txBody>
+          <a:bodyPr rtlCol="0" anchor="ctr"/>
+          <a:lstStyle/>
+          <a:p>
+            <a:pPr algn="ctr"/>
+          </a:p>
+        </p:txBody>
+      </p:sp>
+      <p:sp>
+        <p:nvSpPr>
+          <p:cNvPr id="41" name="Oval 40"/>
+          <p:cNvSpPr/>
+          <p:nvPr/>
+        </p:nvSpPr>
+        <p:spPr>
+          <a:xfrm>
+            <a:off x="8718804" y="5253228"/>
+            <a:ext cx="146304" cy="146304"/>
+          </a:xfrm>
+          <a:prstGeom prst="ellipse">
+            <a:avLst/>
+          </a:prstGeom>
+          <a:solidFill>
+            <a:srgbClr val="FFFFFF"/>
+          </a:solidFill>
+          <a:ln w="25400">
+            <a:solidFill>
+              <a:srgbClr val="001F54"/>
+            </a:solidFill>
+          </a:ln>
+        </p:spPr>
+        <p:style>
+          <a:lnRef idx="1">
+            <a:schemeClr val="accent1"/>
+          </a:lnRef>
+          <a:fillRef idx="3">
+            <a:schemeClr val="accent1"/>
+          </a:fillRef>
+          <a:effectRef idx="2">
+            <a:schemeClr val="accent1"/>
+          </a:effectRef>
+          <a:fontRef idx="minor">
+            <a:schemeClr val="lt1"/>
+          </a:fontRef>
+        </p:style>
+        <p:txBody>
+          <a:bodyPr rtlCol="0" anchor="ctr"/>
+          <a:lstStyle/>
+          <a:p>
+            <a:pPr algn="ctr"/>
+          </a:p>
+        </p:txBody>
+      </p:sp>
+      <p:sp>
+        <p:nvSpPr>
+          <p:cNvPr id="42" name="Oval 41"/>
+          <p:cNvSpPr/>
+          <p:nvPr/>
+        </p:nvSpPr>
+        <p:spPr>
+          <a:xfrm>
+            <a:off x="8700516" y="5234940"/>
+            <a:ext cx="182880" cy="182880"/>
+          </a:xfrm>
+          <a:prstGeom prst="ellipse">
+            <a:avLst/>
+          </a:prstGeom>
+          <a:solidFill>
+            <a:srgbClr val="FF8C00"/>
+          </a:solidFill>
+          <a:ln>
+            <a:noFill/>
+          </a:ln>
+        </p:spPr>
+        <p:style>
+          <a:lnRef idx="1">
+            <a:schemeClr val="accent1"/>
+          </a:lnRef>
+          <a:fillRef idx="3">
+            <a:schemeClr val="accent1"/>
+          </a:fillRef>
+          <a:effectRef idx="2">
+            <a:schemeClr val="accent1"/>
+          </a:effectRef>
+          <a:fontRef idx="minor">
+            <a:schemeClr val="lt1"/>
+          </a:fontRef>
+        </p:style>
+        <p:txBody>
+          <a:bodyPr rtlCol="0" anchor="ctr"/>
+          <a:lstStyle/>
+          <a:p>
+            <a:pPr algn="ctr"/>
+          </a:p>
+        </p:txBody>
+      </p:sp>
+      <p:sp>
+        <p:nvSpPr>
+          <p:cNvPr id="43" name="Oval 42"/>
+          <p:cNvSpPr/>
+          <p:nvPr/>
+        </p:nvSpPr>
+        <p:spPr>
+          <a:xfrm>
+            <a:off x="9176004" y="5253228"/>
+            <a:ext cx="146304" cy="146304"/>
+          </a:xfrm>
+          <a:prstGeom prst="ellipse">
+            <a:avLst/>
+          </a:prstGeom>
+          <a:solidFill>
+            <a:srgbClr val="FFFFFF"/>
+          </a:solidFill>
+          <a:ln w="25400">
+            <a:solidFill>
+              <a:srgbClr val="001F54"/>
+            </a:solidFill>
+          </a:ln>
+        </p:spPr>
+        <p:style>
+          <a:lnRef idx="1">
+            <a:schemeClr val="accent1"/>
+          </a:lnRef>
+          <a:fillRef idx="3">
+            <a:schemeClr val="accent1"/>
+          </a:fillRef>
+          <a:effectRef idx="2">
+            <a:schemeClr val="accent1"/>
+          </a:effectRef>
+          <a:fontRef idx="minor">
+            <a:schemeClr val="lt1"/>
+          </a:fontRef>
+        </p:style>
+        <p:txBody>
+          <a:bodyPr rtlCol="0" anchor="ctr"/>
+          <a:lstStyle/>
+          <a:p>
+            <a:pPr algn="ctr"/>
+          </a:p>
+        </p:txBody>
+      </p:sp>
+      <p:sp>
+        <p:nvSpPr>
+          <p:cNvPr id="44" name="Oval 43"/>
+          <p:cNvSpPr/>
+          <p:nvPr/>
+        </p:nvSpPr>
+        <p:spPr>
+          <a:xfrm>
+            <a:off x="9157716" y="5234940"/>
+            <a:ext cx="182880" cy="182880"/>
+          </a:xfrm>
+          <a:prstGeom prst="ellipse">
+            <a:avLst/>
+          </a:prstGeom>
+          <a:solidFill>
+            <a:srgbClr val="00BCD4"/>
+          </a:solidFill>
+          <a:ln>
+            <a:noFill/>
+          </a:ln>
+        </p:spPr>
+        <p:style>
+          <a:lnRef idx="1">
+            <a:schemeClr val="accent1"/>
+          </a:lnRef>
+          <a:fillRef idx="3">
+            <a:schemeClr val="accent1"/>
+          </a:fillRef>
+          <a:effectRef idx="2">
+            <a:schemeClr val="accent1"/>
+          </a:effectRef>
+          <a:fontRef idx="minor">
+            <a:schemeClr val="lt1"/>
+          </a:fontRef>
+        </p:style>
+        <p:txBody>
+          <a:bodyPr rtlCol="0" anchor="ctr"/>
+          <a:lstStyle/>
+          <a:p>
+            <a:pPr algn="ctr"/>
+          </a:p>
+        </p:txBody>
+      </p:sp>
+      <p:sp>
+        <p:nvSpPr>
+          <p:cNvPr id="45" name="Oval 44"/>
+          <p:cNvSpPr/>
+          <p:nvPr/>
+        </p:nvSpPr>
+        <p:spPr>
+          <a:xfrm>
+            <a:off x="9907524" y="5253228"/>
+            <a:ext cx="146304" cy="146304"/>
+          </a:xfrm>
+          <a:prstGeom prst="ellipse">
+            <a:avLst/>
+          </a:prstGeom>
+          <a:solidFill>
+            <a:srgbClr val="FFFFFF"/>
+          </a:solidFill>
+          <a:ln w="25400">
+            <a:solidFill>
+              <a:srgbClr val="001F54"/>
+            </a:solidFill>
+          </a:ln>
+        </p:spPr>
+        <p:style>
+          <a:lnRef idx="1">
+            <a:schemeClr val="accent1"/>
+          </a:lnRef>
+          <a:fillRef idx="3">
+            <a:schemeClr val="accent1"/>
+          </a:fillRef>
+          <a:effectRef idx="2">
+            <a:schemeClr val="accent1"/>
+          </a:effectRef>
+          <a:fontRef idx="minor">
+            <a:schemeClr val="lt1"/>
+          </a:fontRef>
+        </p:style>
+        <p:txBody>
+          <a:bodyPr rtlCol="0" anchor="ctr"/>
+          <a:lstStyle/>
+          <a:p>
+            <a:pPr algn="ctr"/>
+          </a:p>
+        </p:txBody>
+      </p:sp>
+      <p:sp>
+        <p:nvSpPr>
+          <p:cNvPr id="46" name="Oval 45"/>
+          <p:cNvSpPr/>
+          <p:nvPr/>
+        </p:nvSpPr>
+        <p:spPr>
+          <a:xfrm>
+            <a:off x="10547604" y="5253228"/>
+            <a:ext cx="146304" cy="146304"/>
+          </a:xfrm>
+          <a:prstGeom prst="ellipse">
+            <a:avLst/>
+          </a:prstGeom>
+          <a:solidFill>
+            <a:srgbClr val="FFFFFF"/>
+          </a:solidFill>
+          <a:ln w="25400">
+            <a:solidFill>
+              <a:srgbClr val="001F54"/>
+            </a:solidFill>
+          </a:ln>
+        </p:spPr>
+        <p:style>
+          <a:lnRef idx="1">
+            <a:schemeClr val="accent1"/>
+          </a:lnRef>
+          <a:fillRef idx="3">
+            <a:schemeClr val="accent1"/>
+          </a:fillRef>
+          <a:effectRef idx="2">
+            <a:schemeClr val="accent1"/>
+          </a:effectRef>
+          <a:fontRef idx="minor">
+            <a:schemeClr val="lt1"/>
+          </a:fontRef>
+        </p:style>
+        <p:txBody>
+          <a:bodyPr rtlCol="0" anchor="ctr"/>
+          <a:lstStyle/>
+          <a:p>
+            <a:pPr algn="ctr"/>
+          </a:p>
+        </p:txBody>
+      </p:sp>
+      <p:sp>
+        <p:nvSpPr>
+          <p:cNvPr id="47" name="Rounded Rectangle 46"/>
+          <p:cNvSpPr/>
+          <p:nvPr/>
+        </p:nvSpPr>
+        <p:spPr>
+          <a:xfrm>
+            <a:off x="10300716" y="4937759"/>
+            <a:ext cx="640080" cy="201168"/>
+          </a:xfrm>
+          <a:prstGeom prst="roundRect">
+            <a:avLst/>
+          </a:prstGeom>
+          <a:solidFill>
+            <a:srgbClr val="00C853"/>
+          </a:solidFill>
+          <a:ln>
+            <a:noFill/>
+          </a:ln>
+        </p:spPr>
+        <p:style>
+          <a:lnRef idx="1">
+            <a:schemeClr val="accent1"/>
+          </a:lnRef>
+          <a:fillRef idx="3">
+            <a:schemeClr val="accent1"/>
+          </a:fillRef>
+          <a:effectRef idx="2">
+            <a:schemeClr val="accent1"/>
+          </a:effectRef>
+          <a:fontRef idx="minor">
+            <a:schemeClr val="lt1"/>
+          </a:fontRef>
+        </p:style>
+        <p:txBody>
+          <a:bodyPr rtlCol="0" anchor="ctr"/>
+          <a:lstStyle/>
+          <a:p>
+            <a:pPr algn="ctr"/>
+          </a:p>
+        </p:txBody>
+      </p:sp>
+      <p:sp>
+        <p:nvSpPr>
+          <p:cNvPr id="48" name="TextBox 47"/>
+          <p:cNvSpPr txBox="1"/>
+          <p:nvPr/>
+        </p:nvSpPr>
+        <p:spPr>
+          <a:xfrm>
+            <a:off x="10300716" y="4956048"/>
+            <a:ext cx="640080" cy="201168"/>
+          </a:xfrm>
+          <a:prstGeom prst="rect">
+            <a:avLst/>
+          </a:prstGeom>
+          <a:noFill/>
+        </p:spPr>
+        <p:txBody>
+          <a:bodyPr wrap="square">
+            <a:spAutoFit/>
+          </a:bodyPr>
+          <a:lstStyle/>
+          <a:p>
+            <a:pPr algn="ctr"/>
+            <a:r>
+              <a:rPr sz="800" b="1">
+                <a:solidFill>
+                  <a:srgbClr val="FFFFFF"/>
+                </a:solidFill>
+                <a:latin typeface="Malgun Gothic"/>
+              </a:rPr>
+              <a:t>Merge PR</a:t>
+            </a:r>
+          </a:p>
+        </p:txBody>
+      </p:sp>
+      <p:sp>
+        <p:nvSpPr>
+          <p:cNvPr id="49" name="TextBox 48"/>
+          <p:cNvSpPr txBox="1"/>
+          <p:nvPr/>
+        </p:nvSpPr>
+        <p:spPr>
+          <a:xfrm>
+            <a:off x="10058400" y="6492240"/>
+            <a:ext cx="1828800" cy="274320"/>
+          </a:xfrm>
+          <a:prstGeom prst="rect">
+            <a:avLst/>
+          </a:prstGeom>
+          <a:noFill/>
+        </p:spPr>
+        <p:txBody>
+          <a:bodyPr wrap="square">
+            <a:spAutoFit/>
+          </a:bodyPr>
+          <a:lstStyle/>
+          <a:p>
+            <a:pPr algn="r"/>
+            <a:r>
+              <a:rPr sz="1200" b="1">
+                <a:solidFill>
+                  <a:srgbClr val="CED4DA"/>
+                </a:solidFill>
+                <a:latin typeface="Malgun Gothic"/>
+              </a:rPr>
+              <a:t>HYUNDAI MOBIS</a:t>
+            </a:r>
+          </a:p>
+        </p:txBody>
+      </p:sp>
     </p:spTree>
   </p:cSld>
   <p:clrMapOvr>

</xml_diff>

<commit_message>
feat: Add a new Python utility script to generate `slide5_fixed.png` by capturing an HTML page screenshot.
</commit_message>
<xml_diff>
--- a/docs/MBP-T05_ChildLock_결과발표_Final_v2.pptx
+++ b/docs/MBP-T05_ChildLock_결과발표_Final_v2.pptx
@@ -8944,14 +8944,50 @@
       </p:sp>
       <p:sp>
         <p:nvSpPr>
-          <p:cNvPr id="8" name="Rounded Rectangle 7"/>
+          <p:cNvPr id="8" name="TextBox 7"/>
+          <p:cNvSpPr txBox="1"/>
+          <p:nvPr/>
+        </p:nvSpPr>
+        <p:spPr>
+          <a:xfrm>
+            <a:off x="379475" y="1600200"/>
+            <a:ext cx="5303520" cy="548640"/>
+          </a:xfrm>
+          <a:prstGeom prst="rect">
+            <a:avLst/>
+          </a:prstGeom>
+          <a:noFill/>
+        </p:spPr>
+        <p:txBody>
+          <a:bodyPr wrap="square">
+            <a:spAutoFit/>
+          </a:bodyPr>
+          <a:lstStyle/>
+          <a:p>
+            <a:pPr algn="l"/>
+            <a:r>
+              <a:rPr sz="1200" b="0">
+                <a:solidFill>
+                  <a:srgbClr val="212529"/>
+                </a:solidFill>
+                <a:latin typeface="Malgun Gothic"/>
+              </a:rPr>
+              <a:t>• GTest 프레임워크 기반 140개 단위/통합 테스트 100% 통과
+• 시뮬레이션 환경의 동적 입력(차속/센서)에 따른 정상 상태 전이 검증</a:t>
+            </a:r>
+          </a:p>
+        </p:txBody>
+      </p:sp>
+      <p:sp>
+        <p:nvSpPr>
+          <p:cNvPr id="9" name="Rounded Rectangle 8"/>
           <p:cNvSpPr/>
           <p:nvPr/>
         </p:nvSpPr>
         <p:spPr>
           <a:xfrm>
-            <a:off x="379475" y="1737360"/>
-            <a:ext cx="5303520" cy="2194560"/>
+            <a:off x="379475" y="2194560"/>
+            <a:ext cx="5303520" cy="1737360"/>
           </a:xfrm>
           <a:prstGeom prst="roundRect">
             <a:avLst/>
@@ -8987,13 +9023,13 @@
       </p:sp>
       <p:sp>
         <p:nvSpPr>
-          <p:cNvPr id="9" name="Rounded Rectangle 8"/>
+          <p:cNvPr id="10" name="Rounded Rectangle 9"/>
           <p:cNvSpPr/>
           <p:nvPr/>
         </p:nvSpPr>
         <p:spPr>
           <a:xfrm>
-            <a:off x="470915" y="1828800"/>
+            <a:off x="470915" y="2286000"/>
             <a:ext cx="109728" cy="109728"/>
           </a:xfrm>
           <a:prstGeom prst="roundRect">
@@ -9030,13 +9066,13 @@
       </p:sp>
       <p:sp>
         <p:nvSpPr>
-          <p:cNvPr id="10" name="Rounded Rectangle 9"/>
+          <p:cNvPr id="11" name="Rounded Rectangle 10"/>
           <p:cNvSpPr/>
           <p:nvPr/>
         </p:nvSpPr>
         <p:spPr>
           <a:xfrm>
-            <a:off x="653795" y="1828800"/>
+            <a:off x="653795" y="2286000"/>
             <a:ext cx="109728" cy="109728"/>
           </a:xfrm>
           <a:prstGeom prst="roundRect">
@@ -9073,13 +9109,13 @@
       </p:sp>
       <p:sp>
         <p:nvSpPr>
-          <p:cNvPr id="11" name="Rounded Rectangle 10"/>
+          <p:cNvPr id="12" name="Rounded Rectangle 11"/>
           <p:cNvSpPr/>
           <p:nvPr/>
         </p:nvSpPr>
         <p:spPr>
           <a:xfrm>
-            <a:off x="836675" y="1828800"/>
+            <a:off x="836675" y="2286000"/>
             <a:ext cx="109728" cy="109728"/>
           </a:xfrm>
           <a:prstGeom prst="roundRect">
@@ -9116,14 +9152,14 @@
       </p:sp>
       <p:sp>
         <p:nvSpPr>
-          <p:cNvPr id="12" name="TextBox 11"/>
-          <p:cNvSpPr txBox="1"/>
-          <p:nvPr/>
-        </p:nvSpPr>
-        <p:spPr>
-          <a:xfrm>
-            <a:off x="470915" y="2011679"/>
-            <a:ext cx="5120640" cy="1828800"/>
+          <p:cNvPr id="13" name="TextBox 12"/>
+          <p:cNvSpPr txBox="1"/>
+          <p:nvPr/>
+        </p:nvSpPr>
+        <p:spPr>
+          <a:xfrm>
+            <a:off x="470915" y="2468879"/>
+            <a:ext cx="5120640" cy="1371600"/>
           </a:xfrm>
           <a:prstGeom prst="rect">
             <a:avLst/>
@@ -9195,20 +9231,20 @@
       </p:sp>
       <p:sp>
         <p:nvSpPr>
-          <p:cNvPr id="13" name="Rectangle 12"/>
+          <p:cNvPr id="14" name="Rounded Rectangle 13"/>
           <p:cNvSpPr/>
           <p:nvPr/>
         </p:nvSpPr>
         <p:spPr>
           <a:xfrm>
-            <a:off x="379475" y="4206240"/>
-            <a:ext cx="5303520" cy="1920240"/>
-          </a:xfrm>
-          <a:prstGeom prst="rect">
-            <a:avLst/>
-          </a:prstGeom>
-          <a:solidFill>
-            <a:srgbClr val="FFFFFF"/>
+            <a:off x="379475" y="4114800"/>
+            <a:ext cx="5303520" cy="1828800"/>
+          </a:xfrm>
+          <a:prstGeom prst="roundRect">
+            <a:avLst/>
+          </a:prstGeom>
+          <a:solidFill>
+            <a:srgbClr val="1E1E1E"/>
           </a:solidFill>
           <a:ln w="12700">
             <a:solidFill>
@@ -9240,14 +9276,14 @@
       </p:sp>
       <p:sp>
         <p:nvSpPr>
-          <p:cNvPr id="14" name="TextBox 13"/>
-          <p:cNvSpPr txBox="1"/>
-          <p:nvPr/>
-        </p:nvSpPr>
-        <p:spPr>
-          <a:xfrm>
-            <a:off x="470915" y="4297679"/>
-            <a:ext cx="5120640" cy="1737360"/>
+          <p:cNvPr id="15" name="TextBox 14"/>
+          <p:cNvSpPr txBox="1"/>
+          <p:nvPr/>
+        </p:nvSpPr>
+        <p:spPr>
+          <a:xfrm>
+            <a:off x="470915" y="4206240"/>
+            <a:ext cx="5120640" cy="1645920"/>
           </a:xfrm>
           <a:prstGeom prst="rect">
             <a:avLst/>
@@ -9263,7 +9299,7 @@
             <a:r>
               <a:rPr sz="1000">
                 <a:solidFill>
-                  <a:srgbClr val="6C757D"/>
+                  <a:srgbClr val="AAAAAA"/>
                 </a:solidFill>
                 <a:latin typeface="Consolas"/>
               </a:rPr>
@@ -9275,7 +9311,7 @@
             <a:r>
               <a:rPr sz="1000">
                 <a:solidFill>
-                  <a:srgbClr val="005BBB"/>
+                  <a:srgbClr val="64B5F6"/>
                 </a:solidFill>
                 <a:latin typeface="Consolas"/>
               </a:rPr>
@@ -9284,7 +9320,7 @@
             <a:r>
               <a:rPr sz="1000">
                 <a:solidFill>
-                  <a:srgbClr val="212529"/>
+                  <a:srgbClr val="E0E0E0"/>
                 </a:solidFill>
                 <a:latin typeface="Consolas"/>
               </a:rPr>
@@ -9295,7 +9331,7 @@
             <a:r>
               <a:rPr sz="1000">
                 <a:solidFill>
-                  <a:srgbClr val="005BBB"/>
+                  <a:srgbClr val="64B5F6"/>
                 </a:solidFill>
                 <a:latin typeface="Consolas"/>
               </a:rPr>
@@ -9304,7 +9340,7 @@
             <a:r>
               <a:rPr sz="1000">
                 <a:solidFill>
-                  <a:srgbClr val="212529"/>
+                  <a:srgbClr val="E0E0E0"/>
                 </a:solidFill>
                 <a:latin typeface="Consolas"/>
               </a:rPr>
@@ -9315,7 +9351,7 @@
             <a:r>
               <a:rPr sz="1000">
                 <a:solidFill>
-                  <a:srgbClr val="005BBB"/>
+                  <a:srgbClr val="64B5F6"/>
                 </a:solidFill>
                 <a:latin typeface="Consolas"/>
               </a:rPr>
@@ -9324,7 +9360,7 @@
             <a:r>
               <a:rPr sz="1000">
                 <a:solidFill>
-                  <a:srgbClr val="212529"/>
+                  <a:srgbClr val="E0E0E0"/>
                 </a:solidFill>
                 <a:latin typeface="Consolas"/>
               </a:rPr>
@@ -9335,7 +9371,7 @@
       </p:sp>
       <p:sp>
         <p:nvSpPr>
-          <p:cNvPr id="15" name="Rounded Rectangle 14"/>
+          <p:cNvPr id="16" name="Rounded Rectangle 15"/>
           <p:cNvSpPr/>
           <p:nvPr/>
         </p:nvSpPr>
@@ -9380,7 +9416,7 @@
       </p:sp>
       <p:sp>
         <p:nvSpPr>
-          <p:cNvPr id="16" name="TextBox 15"/>
+          <p:cNvPr id="17" name="TextBox 16"/>
           <p:cNvSpPr txBox="1"/>
           <p:nvPr/>
         </p:nvSpPr>
@@ -9415,14 +9451,50 @@
       </p:sp>
       <p:sp>
         <p:nvSpPr>
-          <p:cNvPr id="17" name="Rounded Rectangle 16"/>
+          <p:cNvPr id="18" name="TextBox 17"/>
+          <p:cNvSpPr txBox="1"/>
+          <p:nvPr/>
+        </p:nvSpPr>
+        <p:spPr>
+          <a:xfrm>
+            <a:off x="6505956" y="1600200"/>
+            <a:ext cx="5303520" cy="548640"/>
+          </a:xfrm>
+          <a:prstGeom prst="rect">
+            <a:avLst/>
+          </a:prstGeom>
+          <a:noFill/>
+        </p:spPr>
+        <p:txBody>
+          <a:bodyPr wrap="square">
+            <a:spAutoFit/>
+          </a:bodyPr>
+          <a:lstStyle/>
+          <a:p>
+            <a:pPr algn="l"/>
+            <a:r>
+              <a:rPr sz="1200" b="0">
+                <a:solidFill>
+                  <a:srgbClr val="212529"/>
+                </a:solidFill>
+                <a:latin typeface="Malgun Gothic"/>
+              </a:rPr>
+              <a:t>• GitHub Actions 기반 빌드 ∙ 테스트 ∙ 정적 분석(Cppcheck) 자동화
+• 기능 개발(feat) 및 버그 수정(fix) 후 main 브랜치로 병합하는 워크플로우</a:t>
+            </a:r>
+          </a:p>
+        </p:txBody>
+      </p:sp>
+      <p:sp>
+        <p:nvSpPr>
+          <p:cNvPr id="19" name="Rounded Rectangle 18"/>
           <p:cNvSpPr/>
           <p:nvPr/>
         </p:nvSpPr>
         <p:spPr>
           <a:xfrm>
-            <a:off x="6505956" y="1737360"/>
-            <a:ext cx="5303520" cy="2194560"/>
+            <a:off x="6505956" y="2194560"/>
+            <a:ext cx="5303520" cy="1828800"/>
           </a:xfrm>
           <a:prstGeom prst="roundRect">
             <a:avLst/>
@@ -9460,13 +9532,13 @@
       </p:sp>
       <p:sp>
         <p:nvSpPr>
-          <p:cNvPr id="18" name="TextBox 17"/>
-          <p:cNvSpPr txBox="1"/>
-          <p:nvPr/>
-        </p:nvSpPr>
-        <p:spPr>
-          <a:xfrm>
-            <a:off x="6597396" y="1828800"/>
+          <p:cNvPr id="20" name="TextBox 19"/>
+          <p:cNvSpPr txBox="1"/>
+          <p:nvPr/>
+        </p:nvSpPr>
+        <p:spPr>
+          <a:xfrm>
+            <a:off x="6597396" y="2286000"/>
             <a:ext cx="5303520" cy="182880"/>
           </a:xfrm>
           <a:prstGeom prst="rect">
@@ -9495,13 +9567,13 @@
       </p:sp>
       <p:sp>
         <p:nvSpPr>
-          <p:cNvPr id="19" name="TextBox 18"/>
-          <p:cNvSpPr txBox="1"/>
-          <p:nvPr/>
-        </p:nvSpPr>
-        <p:spPr>
-          <a:xfrm>
-            <a:off x="6597396" y="2057400"/>
+          <p:cNvPr id="21" name="TextBox 20"/>
+          <p:cNvSpPr txBox="1"/>
+          <p:nvPr/>
+        </p:nvSpPr>
+        <p:spPr>
+          <a:xfrm>
+            <a:off x="6597396" y="2514600"/>
             <a:ext cx="5303520" cy="182880"/>
           </a:xfrm>
           <a:prstGeom prst="rect">
@@ -9530,13 +9602,13 @@
       </p:sp>
       <p:sp>
         <p:nvSpPr>
-          <p:cNvPr id="20" name="TextBox 19"/>
-          <p:cNvSpPr txBox="1"/>
-          <p:nvPr/>
-        </p:nvSpPr>
-        <p:spPr>
-          <a:xfrm>
-            <a:off x="6643116" y="2423160"/>
+          <p:cNvPr id="22" name="TextBox 21"/>
+          <p:cNvSpPr txBox="1"/>
+          <p:nvPr/>
+        </p:nvSpPr>
+        <p:spPr>
+          <a:xfrm>
+            <a:off x="6643116" y="2697480"/>
             <a:ext cx="274320" cy="274320"/>
           </a:xfrm>
           <a:prstGeom prst="rect">
@@ -9565,13 +9637,13 @@
       </p:sp>
       <p:sp>
         <p:nvSpPr>
-          <p:cNvPr id="21" name="TextBox 20"/>
-          <p:cNvSpPr txBox="1"/>
-          <p:nvPr/>
-        </p:nvSpPr>
-        <p:spPr>
-          <a:xfrm>
-            <a:off x="6871716" y="2450592"/>
+          <p:cNvPr id="23" name="TextBox 22"/>
+          <p:cNvSpPr txBox="1"/>
+          <p:nvPr/>
+        </p:nvSpPr>
+        <p:spPr>
+          <a:xfrm>
+            <a:off x="6871716" y="2724912"/>
             <a:ext cx="2743200" cy="228600"/>
           </a:xfrm>
           <a:prstGeom prst="rect">
@@ -9600,13 +9672,99 @@
       </p:sp>
       <p:sp>
         <p:nvSpPr>
-          <p:cNvPr id="22" name="TextBox 21"/>
-          <p:cNvSpPr txBox="1"/>
-          <p:nvPr/>
-        </p:nvSpPr>
-        <p:spPr>
-          <a:xfrm>
-            <a:off x="6643116" y="2743200"/>
+          <p:cNvPr id="24" name="Rounded Rectangle 23"/>
+          <p:cNvSpPr/>
+          <p:nvPr/>
+        </p:nvSpPr>
+        <p:spPr>
+          <a:xfrm>
+            <a:off x="8791956" y="2816351"/>
+            <a:ext cx="1371600" cy="73152"/>
+          </a:xfrm>
+          <a:prstGeom prst="roundRect">
+            <a:avLst/>
+          </a:prstGeom>
+          <a:solidFill>
+            <a:srgbClr val="E3F2FD"/>
+          </a:solidFill>
+          <a:ln>
+            <a:noFill/>
+          </a:ln>
+        </p:spPr>
+        <p:style>
+          <a:lnRef idx="1">
+            <a:schemeClr val="accent1"/>
+          </a:lnRef>
+          <a:fillRef idx="3">
+            <a:schemeClr val="accent1"/>
+          </a:fillRef>
+          <a:effectRef idx="2">
+            <a:schemeClr val="accent1"/>
+          </a:effectRef>
+          <a:fontRef idx="minor">
+            <a:schemeClr val="lt1"/>
+          </a:fontRef>
+        </p:style>
+        <p:txBody>
+          <a:bodyPr rtlCol="0" anchor="ctr"/>
+          <a:lstStyle/>
+          <a:p>
+            <a:pPr algn="ctr"/>
+          </a:p>
+        </p:txBody>
+      </p:sp>
+      <p:sp>
+        <p:nvSpPr>
+          <p:cNvPr id="25" name="Rounded Rectangle 24"/>
+          <p:cNvSpPr/>
+          <p:nvPr/>
+        </p:nvSpPr>
+        <p:spPr>
+          <a:xfrm>
+            <a:off x="8791956" y="2816351"/>
+            <a:ext cx="1371600" cy="73152"/>
+          </a:xfrm>
+          <a:prstGeom prst="roundRect">
+            <a:avLst/>
+          </a:prstGeom>
+          <a:solidFill>
+            <a:srgbClr val="00C853"/>
+          </a:solidFill>
+          <a:ln>
+            <a:noFill/>
+          </a:ln>
+        </p:spPr>
+        <p:style>
+          <a:lnRef idx="1">
+            <a:schemeClr val="accent1"/>
+          </a:lnRef>
+          <a:fillRef idx="3">
+            <a:schemeClr val="accent1"/>
+          </a:fillRef>
+          <a:effectRef idx="2">
+            <a:schemeClr val="accent1"/>
+          </a:effectRef>
+          <a:fontRef idx="minor">
+            <a:schemeClr val="lt1"/>
+          </a:fontRef>
+        </p:style>
+        <p:txBody>
+          <a:bodyPr rtlCol="0" anchor="ctr"/>
+          <a:lstStyle/>
+          <a:p>
+            <a:pPr algn="ctr"/>
+          </a:p>
+        </p:txBody>
+      </p:sp>
+      <p:sp>
+        <p:nvSpPr>
+          <p:cNvPr id="26" name="TextBox 25"/>
+          <p:cNvSpPr txBox="1"/>
+          <p:nvPr/>
+        </p:nvSpPr>
+        <p:spPr>
+          <a:xfrm>
+            <a:off x="6643116" y="2971800"/>
             <a:ext cx="274320" cy="274320"/>
           </a:xfrm>
           <a:prstGeom prst="rect">
@@ -9635,13 +9793,13 @@
       </p:sp>
       <p:sp>
         <p:nvSpPr>
-          <p:cNvPr id="23" name="TextBox 22"/>
-          <p:cNvSpPr txBox="1"/>
-          <p:nvPr/>
-        </p:nvSpPr>
-        <p:spPr>
-          <a:xfrm>
-            <a:off x="6871716" y="2770632"/>
+          <p:cNvPr id="27" name="TextBox 26"/>
+          <p:cNvSpPr txBox="1"/>
+          <p:nvPr/>
+        </p:nvSpPr>
+        <p:spPr>
+          <a:xfrm>
+            <a:off x="6871716" y="2999232"/>
             <a:ext cx="2743200" cy="228600"/>
           </a:xfrm>
           <a:prstGeom prst="rect">
@@ -9664,146 +9822,6 @@
                 <a:latin typeface="Malgun Gothic"/>
               </a:rPr>
               <a:t>Unit Tests (GTest)</a:t>
-            </a:r>
-          </a:p>
-        </p:txBody>
-      </p:sp>
-      <p:sp>
-        <p:nvSpPr>
-          <p:cNvPr id="24" name="TextBox 23"/>
-          <p:cNvSpPr txBox="1"/>
-          <p:nvPr/>
-        </p:nvSpPr>
-        <p:spPr>
-          <a:xfrm>
-            <a:off x="6643116" y="3063240"/>
-            <a:ext cx="274320" cy="274320"/>
-          </a:xfrm>
-          <a:prstGeom prst="rect">
-            <a:avLst/>
-          </a:prstGeom>
-          <a:noFill/>
-        </p:spPr>
-        <p:txBody>
-          <a:bodyPr wrap="square">
-            <a:spAutoFit/>
-          </a:bodyPr>
-          <a:lstStyle/>
-          <a:p>
-            <a:pPr algn="l"/>
-            <a:r>
-              <a:rPr sz="1200" b="1">
-                <a:solidFill>
-                  <a:srgbClr val="00C853"/>
-                </a:solidFill>
-                <a:latin typeface="Segoe UI Symbol"/>
-              </a:rPr>
-              <a:t>✔</a:t>
-            </a:r>
-          </a:p>
-        </p:txBody>
-      </p:sp>
-      <p:sp>
-        <p:nvSpPr>
-          <p:cNvPr id="25" name="TextBox 24"/>
-          <p:cNvSpPr txBox="1"/>
-          <p:nvPr/>
-        </p:nvSpPr>
-        <p:spPr>
-          <a:xfrm>
-            <a:off x="6871716" y="3090672"/>
-            <a:ext cx="2743200" cy="228600"/>
-          </a:xfrm>
-          <a:prstGeom prst="rect">
-            <a:avLst/>
-          </a:prstGeom>
-          <a:noFill/>
-        </p:spPr>
-        <p:txBody>
-          <a:bodyPr wrap="square">
-            <a:spAutoFit/>
-          </a:bodyPr>
-          <a:lstStyle/>
-          <a:p>
-            <a:pPr algn="l"/>
-            <a:r>
-              <a:rPr sz="1000" b="1">
-                <a:solidFill>
-                  <a:srgbClr val="212529"/>
-                </a:solidFill>
-                <a:latin typeface="Malgun Gothic"/>
-              </a:rPr>
-              <a:t>Static Analysis (Cppcheck)</a:t>
-            </a:r>
-          </a:p>
-        </p:txBody>
-      </p:sp>
-      <p:sp>
-        <p:nvSpPr>
-          <p:cNvPr id="26" name="TextBox 25"/>
-          <p:cNvSpPr txBox="1"/>
-          <p:nvPr/>
-        </p:nvSpPr>
-        <p:spPr>
-          <a:xfrm>
-            <a:off x="6643116" y="3383280"/>
-            <a:ext cx="274320" cy="274320"/>
-          </a:xfrm>
-          <a:prstGeom prst="rect">
-            <a:avLst/>
-          </a:prstGeom>
-          <a:noFill/>
-        </p:spPr>
-        <p:txBody>
-          <a:bodyPr wrap="square">
-            <a:spAutoFit/>
-          </a:bodyPr>
-          <a:lstStyle/>
-          <a:p>
-            <a:pPr algn="l"/>
-            <a:r>
-              <a:rPr sz="1200" b="1">
-                <a:solidFill>
-                  <a:srgbClr val="00C853"/>
-                </a:solidFill>
-                <a:latin typeface="Segoe UI Symbol"/>
-              </a:rPr>
-              <a:t>✔</a:t>
-            </a:r>
-          </a:p>
-        </p:txBody>
-      </p:sp>
-      <p:sp>
-        <p:nvSpPr>
-          <p:cNvPr id="27" name="TextBox 26"/>
-          <p:cNvSpPr txBox="1"/>
-          <p:nvPr/>
-        </p:nvSpPr>
-        <p:spPr>
-          <a:xfrm>
-            <a:off x="6871716" y="3410712"/>
-            <a:ext cx="2743200" cy="228600"/>
-          </a:xfrm>
-          <a:prstGeom prst="rect">
-            <a:avLst/>
-          </a:prstGeom>
-          <a:noFill/>
-        </p:spPr>
-        <p:txBody>
-          <a:bodyPr wrap="square">
-            <a:spAutoFit/>
-          </a:bodyPr>
-          <a:lstStyle/>
-          <a:p>
-            <a:pPr algn="l"/>
-            <a:r>
-              <a:rPr sz="1000" b="1">
-                <a:solidFill>
-                  <a:srgbClr val="212529"/>
-                </a:solidFill>
-                <a:latin typeface="Malgun Gothic"/>
-              </a:rPr>
-              <a:t>Code Complexity (Lizard)</a:t>
             </a:r>
           </a:p>
         </p:txBody>
@@ -9816,8 +9834,406 @@
         </p:nvSpPr>
         <p:spPr>
           <a:xfrm>
+            <a:off x="8791956" y="3090671"/>
+            <a:ext cx="1371600" cy="73152"/>
+          </a:xfrm>
+          <a:prstGeom prst="roundRect">
+            <a:avLst/>
+          </a:prstGeom>
+          <a:solidFill>
+            <a:srgbClr val="E3F2FD"/>
+          </a:solidFill>
+          <a:ln>
+            <a:noFill/>
+          </a:ln>
+        </p:spPr>
+        <p:style>
+          <a:lnRef idx="1">
+            <a:schemeClr val="accent1"/>
+          </a:lnRef>
+          <a:fillRef idx="3">
+            <a:schemeClr val="accent1"/>
+          </a:fillRef>
+          <a:effectRef idx="2">
+            <a:schemeClr val="accent1"/>
+          </a:effectRef>
+          <a:fontRef idx="minor">
+            <a:schemeClr val="lt1"/>
+          </a:fontRef>
+        </p:style>
+        <p:txBody>
+          <a:bodyPr rtlCol="0" anchor="ctr"/>
+          <a:lstStyle/>
+          <a:p>
+            <a:pPr algn="ctr"/>
+          </a:p>
+        </p:txBody>
+      </p:sp>
+      <p:sp>
+        <p:nvSpPr>
+          <p:cNvPr id="29" name="Rounded Rectangle 28"/>
+          <p:cNvSpPr/>
+          <p:nvPr/>
+        </p:nvSpPr>
+        <p:spPr>
+          <a:xfrm>
+            <a:off x="8791956" y="3090671"/>
+            <a:ext cx="1371600" cy="73152"/>
+          </a:xfrm>
+          <a:prstGeom prst="roundRect">
+            <a:avLst/>
+          </a:prstGeom>
+          <a:solidFill>
+            <a:srgbClr val="00C853"/>
+          </a:solidFill>
+          <a:ln>
+            <a:noFill/>
+          </a:ln>
+        </p:spPr>
+        <p:style>
+          <a:lnRef idx="1">
+            <a:schemeClr val="accent1"/>
+          </a:lnRef>
+          <a:fillRef idx="3">
+            <a:schemeClr val="accent1"/>
+          </a:fillRef>
+          <a:effectRef idx="2">
+            <a:schemeClr val="accent1"/>
+          </a:effectRef>
+          <a:fontRef idx="minor">
+            <a:schemeClr val="lt1"/>
+          </a:fontRef>
+        </p:style>
+        <p:txBody>
+          <a:bodyPr rtlCol="0" anchor="ctr"/>
+          <a:lstStyle/>
+          <a:p>
+            <a:pPr algn="ctr"/>
+          </a:p>
+        </p:txBody>
+      </p:sp>
+      <p:sp>
+        <p:nvSpPr>
+          <p:cNvPr id="30" name="TextBox 29"/>
+          <p:cNvSpPr txBox="1"/>
+          <p:nvPr/>
+        </p:nvSpPr>
+        <p:spPr>
+          <a:xfrm>
+            <a:off x="6643116" y="3246120"/>
+            <a:ext cx="274320" cy="274320"/>
+          </a:xfrm>
+          <a:prstGeom prst="rect">
+            <a:avLst/>
+          </a:prstGeom>
+          <a:noFill/>
+        </p:spPr>
+        <p:txBody>
+          <a:bodyPr wrap="square">
+            <a:spAutoFit/>
+          </a:bodyPr>
+          <a:lstStyle/>
+          <a:p>
+            <a:pPr algn="l"/>
+            <a:r>
+              <a:rPr sz="1200" b="1">
+                <a:solidFill>
+                  <a:srgbClr val="00C853"/>
+                </a:solidFill>
+                <a:latin typeface="Segoe UI Symbol"/>
+              </a:rPr>
+              <a:t>✔</a:t>
+            </a:r>
+          </a:p>
+        </p:txBody>
+      </p:sp>
+      <p:sp>
+        <p:nvSpPr>
+          <p:cNvPr id="31" name="TextBox 30"/>
+          <p:cNvSpPr txBox="1"/>
+          <p:nvPr/>
+        </p:nvSpPr>
+        <p:spPr>
+          <a:xfrm>
+            <a:off x="6871716" y="3273551"/>
+            <a:ext cx="2743200" cy="228600"/>
+          </a:xfrm>
+          <a:prstGeom prst="rect">
+            <a:avLst/>
+          </a:prstGeom>
+          <a:noFill/>
+        </p:spPr>
+        <p:txBody>
+          <a:bodyPr wrap="square">
+            <a:spAutoFit/>
+          </a:bodyPr>
+          <a:lstStyle/>
+          <a:p>
+            <a:pPr algn="l"/>
+            <a:r>
+              <a:rPr sz="1000" b="1">
+                <a:solidFill>
+                  <a:srgbClr val="212529"/>
+                </a:solidFill>
+                <a:latin typeface="Malgun Gothic"/>
+              </a:rPr>
+              <a:t>Static Analysis (Cppcheck)</a:t>
+            </a:r>
+          </a:p>
+        </p:txBody>
+      </p:sp>
+      <p:sp>
+        <p:nvSpPr>
+          <p:cNvPr id="32" name="Rounded Rectangle 31"/>
+          <p:cNvSpPr/>
+          <p:nvPr/>
+        </p:nvSpPr>
+        <p:spPr>
+          <a:xfrm>
+            <a:off x="8791956" y="3364991"/>
+            <a:ext cx="1371600" cy="73152"/>
+          </a:xfrm>
+          <a:prstGeom prst="roundRect">
+            <a:avLst/>
+          </a:prstGeom>
+          <a:solidFill>
+            <a:srgbClr val="E3F2FD"/>
+          </a:solidFill>
+          <a:ln>
+            <a:noFill/>
+          </a:ln>
+        </p:spPr>
+        <p:style>
+          <a:lnRef idx="1">
+            <a:schemeClr val="accent1"/>
+          </a:lnRef>
+          <a:fillRef idx="3">
+            <a:schemeClr val="accent1"/>
+          </a:fillRef>
+          <a:effectRef idx="2">
+            <a:schemeClr val="accent1"/>
+          </a:effectRef>
+          <a:fontRef idx="minor">
+            <a:schemeClr val="lt1"/>
+          </a:fontRef>
+        </p:style>
+        <p:txBody>
+          <a:bodyPr rtlCol="0" anchor="ctr"/>
+          <a:lstStyle/>
+          <a:p>
+            <a:pPr algn="ctr"/>
+          </a:p>
+        </p:txBody>
+      </p:sp>
+      <p:sp>
+        <p:nvSpPr>
+          <p:cNvPr id="33" name="Rounded Rectangle 32"/>
+          <p:cNvSpPr/>
+          <p:nvPr/>
+        </p:nvSpPr>
+        <p:spPr>
+          <a:xfrm>
+            <a:off x="8791956" y="3364991"/>
+            <a:ext cx="1371600" cy="73152"/>
+          </a:xfrm>
+          <a:prstGeom prst="roundRect">
+            <a:avLst/>
+          </a:prstGeom>
+          <a:solidFill>
+            <a:srgbClr val="00C853"/>
+          </a:solidFill>
+          <a:ln>
+            <a:noFill/>
+          </a:ln>
+        </p:spPr>
+        <p:style>
+          <a:lnRef idx="1">
+            <a:schemeClr val="accent1"/>
+          </a:lnRef>
+          <a:fillRef idx="3">
+            <a:schemeClr val="accent1"/>
+          </a:fillRef>
+          <a:effectRef idx="2">
+            <a:schemeClr val="accent1"/>
+          </a:effectRef>
+          <a:fontRef idx="minor">
+            <a:schemeClr val="lt1"/>
+          </a:fontRef>
+        </p:style>
+        <p:txBody>
+          <a:bodyPr rtlCol="0" anchor="ctr"/>
+          <a:lstStyle/>
+          <a:p>
+            <a:pPr algn="ctr"/>
+          </a:p>
+        </p:txBody>
+      </p:sp>
+      <p:sp>
+        <p:nvSpPr>
+          <p:cNvPr id="34" name="TextBox 33"/>
+          <p:cNvSpPr txBox="1"/>
+          <p:nvPr/>
+        </p:nvSpPr>
+        <p:spPr>
+          <a:xfrm>
+            <a:off x="6643116" y="3520439"/>
+            <a:ext cx="274320" cy="274320"/>
+          </a:xfrm>
+          <a:prstGeom prst="rect">
+            <a:avLst/>
+          </a:prstGeom>
+          <a:noFill/>
+        </p:spPr>
+        <p:txBody>
+          <a:bodyPr wrap="square">
+            <a:spAutoFit/>
+          </a:bodyPr>
+          <a:lstStyle/>
+          <a:p>
+            <a:pPr algn="l"/>
+            <a:r>
+              <a:rPr sz="1200" b="1">
+                <a:solidFill>
+                  <a:srgbClr val="00C853"/>
+                </a:solidFill>
+                <a:latin typeface="Segoe UI Symbol"/>
+              </a:rPr>
+              <a:t>✔</a:t>
+            </a:r>
+          </a:p>
+        </p:txBody>
+      </p:sp>
+      <p:sp>
+        <p:nvSpPr>
+          <p:cNvPr id="35" name="TextBox 34"/>
+          <p:cNvSpPr txBox="1"/>
+          <p:nvPr/>
+        </p:nvSpPr>
+        <p:spPr>
+          <a:xfrm>
+            <a:off x="6871716" y="3547871"/>
+            <a:ext cx="2743200" cy="228600"/>
+          </a:xfrm>
+          <a:prstGeom prst="rect">
+            <a:avLst/>
+          </a:prstGeom>
+          <a:noFill/>
+        </p:spPr>
+        <p:txBody>
+          <a:bodyPr wrap="square">
+            <a:spAutoFit/>
+          </a:bodyPr>
+          <a:lstStyle/>
+          <a:p>
+            <a:pPr algn="l"/>
+            <a:r>
+              <a:rPr sz="1000" b="1">
+                <a:solidFill>
+                  <a:srgbClr val="212529"/>
+                </a:solidFill>
+                <a:latin typeface="Malgun Gothic"/>
+              </a:rPr>
+              <a:t>Code Complexity (Lizard)</a:t>
+            </a:r>
+          </a:p>
+        </p:txBody>
+      </p:sp>
+      <p:sp>
+        <p:nvSpPr>
+          <p:cNvPr id="36" name="Rounded Rectangle 35"/>
+          <p:cNvSpPr/>
+          <p:nvPr/>
+        </p:nvSpPr>
+        <p:spPr>
+          <a:xfrm>
+            <a:off x="8791956" y="3639311"/>
+            <a:ext cx="1371600" cy="73152"/>
+          </a:xfrm>
+          <a:prstGeom prst="roundRect">
+            <a:avLst/>
+          </a:prstGeom>
+          <a:solidFill>
+            <a:srgbClr val="E3F2FD"/>
+          </a:solidFill>
+          <a:ln>
+            <a:noFill/>
+          </a:ln>
+        </p:spPr>
+        <p:style>
+          <a:lnRef idx="1">
+            <a:schemeClr val="accent1"/>
+          </a:lnRef>
+          <a:fillRef idx="3">
+            <a:schemeClr val="accent1"/>
+          </a:fillRef>
+          <a:effectRef idx="2">
+            <a:schemeClr val="accent1"/>
+          </a:effectRef>
+          <a:fontRef idx="minor">
+            <a:schemeClr val="lt1"/>
+          </a:fontRef>
+        </p:style>
+        <p:txBody>
+          <a:bodyPr rtlCol="0" anchor="ctr"/>
+          <a:lstStyle/>
+          <a:p>
+            <a:pPr algn="ctr"/>
+          </a:p>
+        </p:txBody>
+      </p:sp>
+      <p:sp>
+        <p:nvSpPr>
+          <p:cNvPr id="37" name="Rounded Rectangle 36"/>
+          <p:cNvSpPr/>
+          <p:nvPr/>
+        </p:nvSpPr>
+        <p:spPr>
+          <a:xfrm>
+            <a:off x="8791956" y="3639311"/>
+            <a:ext cx="1371600" cy="73152"/>
+          </a:xfrm>
+          <a:prstGeom prst="roundRect">
+            <a:avLst/>
+          </a:prstGeom>
+          <a:solidFill>
+            <a:srgbClr val="00C853"/>
+          </a:solidFill>
+          <a:ln>
+            <a:noFill/>
+          </a:ln>
+        </p:spPr>
+        <p:style>
+          <a:lnRef idx="1">
+            <a:schemeClr val="accent1"/>
+          </a:lnRef>
+          <a:fillRef idx="3">
+            <a:schemeClr val="accent1"/>
+          </a:fillRef>
+          <a:effectRef idx="2">
+            <a:schemeClr val="accent1"/>
+          </a:effectRef>
+          <a:fontRef idx="minor">
+            <a:schemeClr val="lt1"/>
+          </a:fontRef>
+        </p:style>
+        <p:txBody>
+          <a:bodyPr rtlCol="0" anchor="ctr"/>
+          <a:lstStyle/>
+          <a:p>
+            <a:pPr algn="ctr"/>
+          </a:p>
+        </p:txBody>
+      </p:sp>
+      <p:sp>
+        <p:nvSpPr>
+          <p:cNvPr id="38" name="Rounded Rectangle 37"/>
+          <p:cNvSpPr/>
+          <p:nvPr/>
+        </p:nvSpPr>
+        <p:spPr>
+          <a:xfrm>
             <a:off x="6505956" y="4206240"/>
-            <a:ext cx="5303520" cy="1920240"/>
+            <a:ext cx="5303520" cy="1737360"/>
           </a:xfrm>
           <a:prstGeom prst="roundRect">
             <a:avLst/>
@@ -9855,13 +10271,13 @@
       </p:sp>
       <p:sp>
         <p:nvSpPr>
-          <p:cNvPr id="29" name="TextBox 28"/>
-          <p:cNvSpPr txBox="1"/>
-          <p:nvPr/>
-        </p:nvSpPr>
-        <p:spPr>
-          <a:xfrm>
-            <a:off x="6597396" y="4297679"/>
+          <p:cNvPr id="39" name="TextBox 38"/>
+          <p:cNvSpPr txBox="1"/>
+          <p:nvPr/>
+        </p:nvSpPr>
+        <p:spPr>
+          <a:xfrm>
+            <a:off x="6597396" y="4297680"/>
             <a:ext cx="5303520" cy="182880"/>
           </a:xfrm>
           <a:prstGeom prst="rect">
@@ -9883,20 +10299,20 @@
                 </a:solidFill>
                 <a:latin typeface="Malgun Gothic"/>
               </a:rPr>
-              <a:t>Branch Workflow</a:t>
-            </a:r>
-          </a:p>
-        </p:txBody>
-      </p:sp>
-      <p:sp>
-        <p:nvSpPr>
-          <p:cNvPr id="30" name="Rectangle 29"/>
+              <a:t>Branch Network Graph</a:t>
+            </a:r>
+          </a:p>
+        </p:txBody>
+      </p:sp>
+      <p:sp>
+        <p:nvSpPr>
+          <p:cNvPr id="40" name="Rectangle 39"/>
           <p:cNvSpPr/>
           <p:nvPr/>
         </p:nvSpPr>
         <p:spPr>
           <a:xfrm>
-            <a:off x="6780276" y="5303520"/>
+            <a:off x="6780276" y="5120640"/>
             <a:ext cx="4572000" cy="45720"/>
           </a:xfrm>
           <a:prstGeom prst="rect">
@@ -9933,13 +10349,13 @@
       </p:sp>
       <p:sp>
         <p:nvSpPr>
-          <p:cNvPr id="31" name="TextBox 30"/>
-          <p:cNvSpPr txBox="1"/>
-          <p:nvPr/>
-        </p:nvSpPr>
-        <p:spPr>
-          <a:xfrm>
-            <a:off x="6780276" y="5029200"/>
+          <p:cNvPr id="41" name="TextBox 40"/>
+          <p:cNvSpPr txBox="1"/>
+          <p:nvPr/>
+        </p:nvSpPr>
+        <p:spPr>
+          <a:xfrm>
+            <a:off x="6780276" y="4846320"/>
             <a:ext cx="731520" cy="182880"/>
           </a:xfrm>
           <a:prstGeom prst="rect">
@@ -9968,13 +10384,13 @@
       </p:sp>
       <p:sp>
         <p:nvSpPr>
-          <p:cNvPr id="32" name="Rectangle 31"/>
+          <p:cNvPr id="42" name="Rectangle 41"/>
           <p:cNvSpPr/>
           <p:nvPr/>
         </p:nvSpPr>
         <p:spPr>
           <a:xfrm>
-            <a:off x="7237476" y="4754879"/>
+            <a:off x="7237476" y="4663440"/>
             <a:ext cx="1554480" cy="36576"/>
           </a:xfrm>
           <a:prstGeom prst="rect">
@@ -10011,18 +10427,24 @@
       </p:sp>
       <p:sp>
         <p:nvSpPr>
-          <p:cNvPr id="33" name="Straight Connector 32"/>
+          <p:cNvPr id="43" name="Rectangle 42"/>
           <p:cNvSpPr/>
           <p:nvPr/>
         </p:nvSpPr>
         <p:spPr>
           <a:xfrm>
-            <a:off x="8791956" y="4754879"/>
-            <a:ext cx="457200" cy="548640"/>
-          </a:xfrm>
-          <a:prstGeom prst="lineInv">
-            <a:avLst/>
-          </a:prstGeom>
+            <a:off x="8791956" y="4663440"/>
+            <a:ext cx="36576" cy="457200"/>
+          </a:xfrm>
+          <a:prstGeom prst="rect">
+            <a:avLst/>
+          </a:prstGeom>
+          <a:solidFill>
+            <a:srgbClr val="FF8C00"/>
+          </a:solidFill>
+          <a:ln>
+            <a:noFill/>
+          </a:ln>
         </p:spPr>
         <p:style>
           <a:lnRef idx="1">
@@ -10048,20 +10470,55 @@
       </p:sp>
       <p:sp>
         <p:nvSpPr>
-          <p:cNvPr id="34" name="Rectangle 33"/>
+          <p:cNvPr id="44" name="TextBox 43"/>
+          <p:cNvSpPr txBox="1"/>
+          <p:nvPr/>
+        </p:nvSpPr>
+        <p:spPr>
+          <a:xfrm>
+            <a:off x="7237476" y="4434840"/>
+            <a:ext cx="1371600" cy="182880"/>
+          </a:xfrm>
+          <a:prstGeom prst="rect">
+            <a:avLst/>
+          </a:prstGeom>
+          <a:noFill/>
+        </p:spPr>
+        <p:txBody>
+          <a:bodyPr wrap="square">
+            <a:spAutoFit/>
+          </a:bodyPr>
+          <a:lstStyle/>
+          <a:p>
+            <a:pPr algn="l"/>
+            <a:r>
+              <a:rPr sz="900" b="1">
+                <a:solidFill>
+                  <a:srgbClr val="FF8C00"/>
+                </a:solidFill>
+                <a:latin typeface="Malgun Gothic"/>
+              </a:rPr>
+              <a:t>feat/rear-radar</a:t>
+            </a:r>
+          </a:p>
+        </p:txBody>
+      </p:sp>
+      <p:sp>
+        <p:nvSpPr>
+          <p:cNvPr id="45" name="Rectangle 44"/>
           <p:cNvSpPr/>
           <p:nvPr/>
         </p:nvSpPr>
         <p:spPr>
           <a:xfrm>
-            <a:off x="8791956" y="4754879"/>
-            <a:ext cx="36576" cy="548640"/>
-          </a:xfrm>
-          <a:prstGeom prst="rect">
-            <a:avLst/>
-          </a:prstGeom>
-          <a:solidFill>
-            <a:srgbClr val="FF8C00"/>
+            <a:off x="7877556" y="5577840"/>
+            <a:ext cx="1371600" cy="36576"/>
+          </a:xfrm>
+          <a:prstGeom prst="rect">
+            <a:avLst/>
+          </a:prstGeom>
+          <a:solidFill>
+            <a:srgbClr val="00BCD4"/>
           </a:solidFill>
           <a:ln>
             <a:noFill/>
@@ -10091,49 +10548,14 @@
       </p:sp>
       <p:sp>
         <p:nvSpPr>
-          <p:cNvPr id="35" name="TextBox 34"/>
-          <p:cNvSpPr txBox="1"/>
-          <p:nvPr/>
-        </p:nvSpPr>
-        <p:spPr>
-          <a:xfrm>
-            <a:off x="7237476" y="4526279"/>
-            <a:ext cx="1371600" cy="182880"/>
-          </a:xfrm>
-          <a:prstGeom prst="rect">
-            <a:avLst/>
-          </a:prstGeom>
-          <a:noFill/>
-        </p:spPr>
-        <p:txBody>
-          <a:bodyPr wrap="square">
-            <a:spAutoFit/>
-          </a:bodyPr>
-          <a:lstStyle/>
-          <a:p>
-            <a:pPr algn="l"/>
-            <a:r>
-              <a:rPr sz="900" b="1">
-                <a:solidFill>
-                  <a:srgbClr val="FF8C00"/>
-                </a:solidFill>
-                <a:latin typeface="Malgun Gothic"/>
-              </a:rPr>
-              <a:t>feat/rear-radar</a:t>
-            </a:r>
-          </a:p>
-        </p:txBody>
-      </p:sp>
-      <p:sp>
-        <p:nvSpPr>
-          <p:cNvPr id="36" name="Rectangle 35"/>
+          <p:cNvPr id="46" name="Rectangle 45"/>
           <p:cNvSpPr/>
           <p:nvPr/>
         </p:nvSpPr>
         <p:spPr>
           <a:xfrm>
-            <a:off x="7877556" y="5760720"/>
-            <a:ext cx="1371600" cy="36576"/>
+            <a:off x="9249156" y="5120640"/>
+            <a:ext cx="36576" cy="457200"/>
           </a:xfrm>
           <a:prstGeom prst="rect">
             <a:avLst/>
@@ -10169,23 +10591,60 @@
       </p:sp>
       <p:sp>
         <p:nvSpPr>
-          <p:cNvPr id="37" name="Rectangle 36"/>
+          <p:cNvPr id="47" name="TextBox 46"/>
+          <p:cNvSpPr txBox="1"/>
+          <p:nvPr/>
+        </p:nvSpPr>
+        <p:spPr>
+          <a:xfrm>
+            <a:off x="7877556" y="5623560"/>
+            <a:ext cx="1371600" cy="182880"/>
+          </a:xfrm>
+          <a:prstGeom prst="rect">
+            <a:avLst/>
+          </a:prstGeom>
+          <a:noFill/>
+        </p:spPr>
+        <p:txBody>
+          <a:bodyPr wrap="square">
+            <a:spAutoFit/>
+          </a:bodyPr>
+          <a:lstStyle/>
+          <a:p>
+            <a:pPr algn="l"/>
+            <a:r>
+              <a:rPr sz="900" b="1">
+                <a:solidFill>
+                  <a:srgbClr val="00BCD4"/>
+                </a:solidFill>
+                <a:latin typeface="Malgun Gothic"/>
+              </a:rPr>
+              <a:t>fix/crash-logic</a:t>
+            </a:r>
+          </a:p>
+        </p:txBody>
+      </p:sp>
+      <p:sp>
+        <p:nvSpPr>
+          <p:cNvPr id="48" name="Oval 47"/>
           <p:cNvSpPr/>
           <p:nvPr/>
         </p:nvSpPr>
         <p:spPr>
           <a:xfrm>
-            <a:off x="9249156" y="5303520"/>
-            <a:ext cx="36576" cy="457200"/>
-          </a:xfrm>
-          <a:prstGeom prst="rect">
-            <a:avLst/>
-          </a:prstGeom>
-          <a:solidFill>
-            <a:srgbClr val="00BCD4"/>
-          </a:solidFill>
-          <a:ln>
-            <a:noFill/>
+            <a:off x="7164324" y="5070348"/>
+            <a:ext cx="146304" cy="146304"/>
+          </a:xfrm>
+          <a:prstGeom prst="ellipse">
+            <a:avLst/>
+          </a:prstGeom>
+          <a:solidFill>
+            <a:srgbClr val="FFFFFF"/>
+          </a:solidFill>
+          <a:ln w="25400">
+            <a:solidFill>
+              <a:srgbClr val="001F54"/>
+            </a:solidFill>
           </a:ln>
         </p:spPr>
         <p:style>
@@ -10212,48 +10671,13 @@
       </p:sp>
       <p:sp>
         <p:nvSpPr>
-          <p:cNvPr id="38" name="TextBox 37"/>
-          <p:cNvSpPr txBox="1"/>
-          <p:nvPr/>
-        </p:nvSpPr>
-        <p:spPr>
-          <a:xfrm>
-            <a:off x="7877556" y="5806440"/>
-            <a:ext cx="1371600" cy="182880"/>
-          </a:xfrm>
-          <a:prstGeom prst="rect">
-            <a:avLst/>
-          </a:prstGeom>
-          <a:noFill/>
-        </p:spPr>
-        <p:txBody>
-          <a:bodyPr wrap="square">
-            <a:spAutoFit/>
-          </a:bodyPr>
-          <a:lstStyle/>
-          <a:p>
-            <a:pPr algn="l"/>
-            <a:r>
-              <a:rPr sz="900" b="1">
-                <a:solidFill>
-                  <a:srgbClr val="00BCD4"/>
-                </a:solidFill>
-                <a:latin typeface="Malgun Gothic"/>
-              </a:rPr>
-              <a:t>fix/crash-logic</a:t>
-            </a:r>
-          </a:p>
-        </p:txBody>
-      </p:sp>
-      <p:sp>
-        <p:nvSpPr>
-          <p:cNvPr id="39" name="Oval 38"/>
+          <p:cNvPr id="49" name="Oval 48"/>
           <p:cNvSpPr/>
           <p:nvPr/>
         </p:nvSpPr>
         <p:spPr>
           <a:xfrm>
-            <a:off x="7164324" y="5253228"/>
+            <a:off x="7804404" y="5070348"/>
             <a:ext cx="146304" cy="146304"/>
           </a:xfrm>
           <a:prstGeom prst="ellipse">
@@ -10292,13 +10716,13 @@
       </p:sp>
       <p:sp>
         <p:nvSpPr>
-          <p:cNvPr id="40" name="Oval 39"/>
+          <p:cNvPr id="50" name="Oval 49"/>
           <p:cNvSpPr/>
           <p:nvPr/>
         </p:nvSpPr>
         <p:spPr>
           <a:xfrm>
-            <a:off x="7804404" y="5253228"/>
+            <a:off x="8718804" y="5070348"/>
             <a:ext cx="146304" cy="146304"/>
           </a:xfrm>
           <a:prstGeom prst="ellipse">
@@ -10337,13 +10761,56 @@
       </p:sp>
       <p:sp>
         <p:nvSpPr>
-          <p:cNvPr id="41" name="Oval 40"/>
+          <p:cNvPr id="51" name="Oval 50"/>
           <p:cNvSpPr/>
           <p:nvPr/>
         </p:nvSpPr>
         <p:spPr>
           <a:xfrm>
-            <a:off x="8718804" y="5253228"/>
+            <a:off x="8700516" y="5052060"/>
+            <a:ext cx="182880" cy="182880"/>
+          </a:xfrm>
+          <a:prstGeom prst="ellipse">
+            <a:avLst/>
+          </a:prstGeom>
+          <a:solidFill>
+            <a:srgbClr val="FF8C00"/>
+          </a:solidFill>
+          <a:ln>
+            <a:noFill/>
+          </a:ln>
+        </p:spPr>
+        <p:style>
+          <a:lnRef idx="1">
+            <a:schemeClr val="accent1"/>
+          </a:lnRef>
+          <a:fillRef idx="3">
+            <a:schemeClr val="accent1"/>
+          </a:fillRef>
+          <a:effectRef idx="2">
+            <a:schemeClr val="accent1"/>
+          </a:effectRef>
+          <a:fontRef idx="minor">
+            <a:schemeClr val="lt1"/>
+          </a:fontRef>
+        </p:style>
+        <p:txBody>
+          <a:bodyPr rtlCol="0" anchor="ctr"/>
+          <a:lstStyle/>
+          <a:p>
+            <a:pPr algn="ctr"/>
+          </a:p>
+        </p:txBody>
+      </p:sp>
+      <p:sp>
+        <p:nvSpPr>
+          <p:cNvPr id="52" name="Oval 51"/>
+          <p:cNvSpPr/>
+          <p:nvPr/>
+        </p:nvSpPr>
+        <p:spPr>
+          <a:xfrm>
+            <a:off x="9176004" y="5070348"/>
             <a:ext cx="146304" cy="146304"/>
           </a:xfrm>
           <a:prstGeom prst="ellipse">
@@ -10382,20 +10849,20 @@
       </p:sp>
       <p:sp>
         <p:nvSpPr>
-          <p:cNvPr id="42" name="Oval 41"/>
+          <p:cNvPr id="53" name="Oval 52"/>
           <p:cNvSpPr/>
           <p:nvPr/>
         </p:nvSpPr>
         <p:spPr>
           <a:xfrm>
-            <a:off x="8700516" y="5234940"/>
+            <a:off x="9157716" y="5052060"/>
             <a:ext cx="182880" cy="182880"/>
           </a:xfrm>
           <a:prstGeom prst="ellipse">
             <a:avLst/>
           </a:prstGeom>
           <a:solidFill>
-            <a:srgbClr val="FF8C00"/>
+            <a:srgbClr val="00BCD4"/>
           </a:solidFill>
           <a:ln>
             <a:noFill/>
@@ -10425,13 +10892,13 @@
       </p:sp>
       <p:sp>
         <p:nvSpPr>
-          <p:cNvPr id="43" name="Oval 42"/>
+          <p:cNvPr id="54" name="Oval 53"/>
           <p:cNvSpPr/>
           <p:nvPr/>
         </p:nvSpPr>
         <p:spPr>
           <a:xfrm>
-            <a:off x="9176004" y="5253228"/>
+            <a:off x="9907524" y="5070348"/>
             <a:ext cx="146304" cy="146304"/>
           </a:xfrm>
           <a:prstGeom prst="ellipse">
@@ -10470,23 +10937,25 @@
       </p:sp>
       <p:sp>
         <p:nvSpPr>
-          <p:cNvPr id="44" name="Oval 43"/>
+          <p:cNvPr id="55" name="Oval 54"/>
           <p:cNvSpPr/>
           <p:nvPr/>
         </p:nvSpPr>
         <p:spPr>
           <a:xfrm>
-            <a:off x="9157716" y="5234940"/>
-            <a:ext cx="182880" cy="182880"/>
+            <a:off x="10547604" y="5070348"/>
+            <a:ext cx="146304" cy="146304"/>
           </a:xfrm>
           <a:prstGeom prst="ellipse">
             <a:avLst/>
           </a:prstGeom>
           <a:solidFill>
-            <a:srgbClr val="00BCD4"/>
-          </a:solidFill>
-          <a:ln>
-            <a:noFill/>
+            <a:srgbClr val="FFFFFF"/>
+          </a:solidFill>
+          <a:ln w="25400">
+            <a:solidFill>
+              <a:srgbClr val="001F54"/>
+            </a:solidFill>
           </a:ln>
         </p:spPr>
         <p:style>
@@ -10513,25 +10982,23 @@
       </p:sp>
       <p:sp>
         <p:nvSpPr>
-          <p:cNvPr id="45" name="Oval 44"/>
+          <p:cNvPr id="56" name="Rounded Rectangle 55"/>
           <p:cNvSpPr/>
           <p:nvPr/>
         </p:nvSpPr>
         <p:spPr>
           <a:xfrm>
-            <a:off x="9907524" y="5253228"/>
-            <a:ext cx="146304" cy="146304"/>
-          </a:xfrm>
-          <a:prstGeom prst="ellipse">
-            <a:avLst/>
-          </a:prstGeom>
-          <a:solidFill>
-            <a:srgbClr val="FFFFFF"/>
-          </a:solidFill>
-          <a:ln w="25400">
-            <a:solidFill>
-              <a:srgbClr val="001F54"/>
-            </a:solidFill>
+            <a:off x="10300716" y="4800600"/>
+            <a:ext cx="640080" cy="201168"/>
+          </a:xfrm>
+          <a:prstGeom prst="roundRect">
+            <a:avLst/>
+          </a:prstGeom>
+          <a:solidFill>
+            <a:srgbClr val="00C853"/>
+          </a:solidFill>
+          <a:ln>
+            <a:noFill/>
           </a:ln>
         </p:spPr>
         <p:style>
@@ -10558,103 +11025,15 @@
       </p:sp>
       <p:sp>
         <p:nvSpPr>
-          <p:cNvPr id="46" name="Oval 45"/>
-          <p:cNvSpPr/>
-          <p:nvPr/>
-        </p:nvSpPr>
-        <p:spPr>
-          <a:xfrm>
-            <a:off x="10547604" y="5253228"/>
-            <a:ext cx="146304" cy="146304"/>
-          </a:xfrm>
-          <a:prstGeom prst="ellipse">
-            <a:avLst/>
-          </a:prstGeom>
-          <a:solidFill>
-            <a:srgbClr val="FFFFFF"/>
-          </a:solidFill>
-          <a:ln w="25400">
-            <a:solidFill>
-              <a:srgbClr val="001F54"/>
-            </a:solidFill>
-          </a:ln>
-        </p:spPr>
-        <p:style>
-          <a:lnRef idx="1">
-            <a:schemeClr val="accent1"/>
-          </a:lnRef>
-          <a:fillRef idx="3">
-            <a:schemeClr val="accent1"/>
-          </a:fillRef>
-          <a:effectRef idx="2">
-            <a:schemeClr val="accent1"/>
-          </a:effectRef>
-          <a:fontRef idx="minor">
-            <a:schemeClr val="lt1"/>
-          </a:fontRef>
-        </p:style>
-        <p:txBody>
-          <a:bodyPr rtlCol="0" anchor="ctr"/>
-          <a:lstStyle/>
-          <a:p>
-            <a:pPr algn="ctr"/>
-          </a:p>
-        </p:txBody>
-      </p:sp>
-      <p:sp>
-        <p:nvSpPr>
-          <p:cNvPr id="47" name="Rounded Rectangle 46"/>
-          <p:cNvSpPr/>
-          <p:nvPr/>
-        </p:nvSpPr>
-        <p:spPr>
-          <a:xfrm>
-            <a:off x="10300716" y="4937759"/>
+          <p:cNvPr id="57" name="TextBox 56"/>
+          <p:cNvSpPr txBox="1"/>
+          <p:nvPr/>
+        </p:nvSpPr>
+        <p:spPr>
+          <a:xfrm>
+            <a:off x="10300716" y="4818888"/>
             <a:ext cx="640080" cy="201168"/>
           </a:xfrm>
-          <a:prstGeom prst="roundRect">
-            <a:avLst/>
-          </a:prstGeom>
-          <a:solidFill>
-            <a:srgbClr val="00C853"/>
-          </a:solidFill>
-          <a:ln>
-            <a:noFill/>
-          </a:ln>
-        </p:spPr>
-        <p:style>
-          <a:lnRef idx="1">
-            <a:schemeClr val="accent1"/>
-          </a:lnRef>
-          <a:fillRef idx="3">
-            <a:schemeClr val="accent1"/>
-          </a:fillRef>
-          <a:effectRef idx="2">
-            <a:schemeClr val="accent1"/>
-          </a:effectRef>
-          <a:fontRef idx="minor">
-            <a:schemeClr val="lt1"/>
-          </a:fontRef>
-        </p:style>
-        <p:txBody>
-          <a:bodyPr rtlCol="0" anchor="ctr"/>
-          <a:lstStyle/>
-          <a:p>
-            <a:pPr algn="ctr"/>
-          </a:p>
-        </p:txBody>
-      </p:sp>
-      <p:sp>
-        <p:nvSpPr>
-          <p:cNvPr id="48" name="TextBox 47"/>
-          <p:cNvSpPr txBox="1"/>
-          <p:nvPr/>
-        </p:nvSpPr>
-        <p:spPr>
-          <a:xfrm>
-            <a:off x="10300716" y="4956048"/>
-            <a:ext cx="640080" cy="201168"/>
-          </a:xfrm>
           <a:prstGeom prst="rect">
             <a:avLst/>
           </a:prstGeom>
@@ -10681,7 +11060,7 @@
       </p:sp>
       <p:sp>
         <p:nvSpPr>
-          <p:cNvPr id="49" name="TextBox 48"/>
+          <p:cNvPr id="58" name="TextBox 57"/>
           <p:cNvSpPr txBox="1"/>
           <p:nvPr/>
         </p:nvSpPr>

</xml_diff>